<commit_message>
updating workflow diagram to include Reactome
</commit_message>
<xml_diff>
--- a/i5k_workflow_diagram.pptx
+++ b/i5k_workflow_diagram.pptx
@@ -1,19 +1,19 @@
 
 <file path=ppt/presentation.xml><?xml version="1.0" encoding="utf-8"?>
-<p:presentation xmlns:a="http://schemas.openxmlformats.org/drawingml/2006/main" xmlns:r="http://schemas.openxmlformats.org/officeDocument/2006/relationships" xmlns:mc="http://schemas.openxmlformats.org/markup-compatibility/2006" xmlns:mv="urn:schemas-microsoft-com:mac:vml" xmlns:p="http://schemas.openxmlformats.org/presentationml/2006/main" xmlns:c="http://schemas.openxmlformats.org/drawingml/2006/chart" xmlns:dgm="http://schemas.openxmlformats.org/drawingml/2006/diagram" xmlns:o="urn:schemas-microsoft-com:office:office" xmlns:v="urn:schemas-microsoft-com:vml" xmlns:pvml="urn:schemas-microsoft-com:office:powerpoint" xmlns:com="http://schemas.openxmlformats.org/drawingml/2006/compatibility" xmlns:p14="http://schemas.microsoft.com/office/powerpoint/2010/main" xmlns:p15="http://schemas.microsoft.com/office/powerpoint/2012/main" xmlns:ahyp="http://schemas.microsoft.com/office/drawing/2018/hyperlinkcolor" autoCompressPictures="0" strictFirstAndLastChars="0" saveSubsetFonts="1">
+<p:presentation xmlns:a="http://schemas.openxmlformats.org/drawingml/2006/main" xmlns:r="http://schemas.openxmlformats.org/officeDocument/2006/relationships" xmlns:p="http://schemas.openxmlformats.org/presentationml/2006/main" strictFirstAndLastChars="0" saveSubsetFonts="1" autoCompressPictures="0">
   <p:sldMasterIdLst>
-    <p:sldMasterId id="2147483659" r:id="rId4"/>
+    <p:sldMasterId id="2147483659" r:id="rId1"/>
   </p:sldMasterIdLst>
   <p:notesMasterIdLst>
-    <p:notesMasterId r:id="rId5"/>
+    <p:notesMasterId r:id="rId3"/>
   </p:notesMasterIdLst>
   <p:sldIdLst>
-    <p:sldId id="256" r:id="rId6"/>
+    <p:sldId id="256" r:id="rId2"/>
   </p:sldIdLst>
-  <p:sldSz cy="5143500" cx="9144000"/>
+  <p:sldSz cx="9144000" cy="5143500" type="screen16x9"/>
   <p:notesSz cx="6858000" cy="9144000"/>
   <p:defaultTextStyle>
-    <a:defPPr lvl="0" marR="0" rtl="0" algn="l">
+    <a:defPPr marR="0" lvl="0" algn="l" rtl="0">
       <a:lnSpc>
         <a:spcPct val="100000"/>
       </a:lnSpc>
@@ -24,7 +24,7 @@
         <a:spcPts val="0"/>
       </a:spcAft>
     </a:defPPr>
-    <a:lvl1pPr lvl="0" marR="0" rtl="0" algn="l">
+    <a:lvl1pPr marR="0" lvl="0" algn="l" rtl="0">
       <a:lnSpc>
         <a:spcPct val="100000"/>
       </a:lnSpc>
@@ -38,7 +38,7 @@
         <a:srgbClr val="000000"/>
       </a:buClr>
       <a:buFont typeface="Arial"/>
-      <a:defRPr b="0" i="0" sz="1400" u="none" cap="none" strike="noStrike">
+      <a:defRPr sz="1400" b="0" i="0" u="none" strike="noStrike" cap="none">
         <a:solidFill>
           <a:srgbClr val="000000"/>
         </a:solidFill>
@@ -48,7 +48,7 @@
         <a:sym typeface="Arial"/>
       </a:defRPr>
     </a:lvl1pPr>
-    <a:lvl2pPr lvl="1" marR="0" rtl="0" algn="l">
+    <a:lvl2pPr marR="0" lvl="1" algn="l" rtl="0">
       <a:lnSpc>
         <a:spcPct val="100000"/>
       </a:lnSpc>
@@ -62,7 +62,7 @@
         <a:srgbClr val="000000"/>
       </a:buClr>
       <a:buFont typeface="Arial"/>
-      <a:defRPr b="0" i="0" sz="1400" u="none" cap="none" strike="noStrike">
+      <a:defRPr sz="1400" b="0" i="0" u="none" strike="noStrike" cap="none">
         <a:solidFill>
           <a:srgbClr val="000000"/>
         </a:solidFill>
@@ -72,7 +72,7 @@
         <a:sym typeface="Arial"/>
       </a:defRPr>
     </a:lvl2pPr>
-    <a:lvl3pPr lvl="2" marR="0" rtl="0" algn="l">
+    <a:lvl3pPr marR="0" lvl="2" algn="l" rtl="0">
       <a:lnSpc>
         <a:spcPct val="100000"/>
       </a:lnSpc>
@@ -86,7 +86,7 @@
         <a:srgbClr val="000000"/>
       </a:buClr>
       <a:buFont typeface="Arial"/>
-      <a:defRPr b="0" i="0" sz="1400" u="none" cap="none" strike="noStrike">
+      <a:defRPr sz="1400" b="0" i="0" u="none" strike="noStrike" cap="none">
         <a:solidFill>
           <a:srgbClr val="000000"/>
         </a:solidFill>
@@ -96,7 +96,7 @@
         <a:sym typeface="Arial"/>
       </a:defRPr>
     </a:lvl3pPr>
-    <a:lvl4pPr lvl="3" marR="0" rtl="0" algn="l">
+    <a:lvl4pPr marR="0" lvl="3" algn="l" rtl="0">
       <a:lnSpc>
         <a:spcPct val="100000"/>
       </a:lnSpc>
@@ -110,7 +110,7 @@
         <a:srgbClr val="000000"/>
       </a:buClr>
       <a:buFont typeface="Arial"/>
-      <a:defRPr b="0" i="0" sz="1400" u="none" cap="none" strike="noStrike">
+      <a:defRPr sz="1400" b="0" i="0" u="none" strike="noStrike" cap="none">
         <a:solidFill>
           <a:srgbClr val="000000"/>
         </a:solidFill>
@@ -120,7 +120,7 @@
         <a:sym typeface="Arial"/>
       </a:defRPr>
     </a:lvl4pPr>
-    <a:lvl5pPr lvl="4" marR="0" rtl="0" algn="l">
+    <a:lvl5pPr marR="0" lvl="4" algn="l" rtl="0">
       <a:lnSpc>
         <a:spcPct val="100000"/>
       </a:lnSpc>
@@ -134,7 +134,7 @@
         <a:srgbClr val="000000"/>
       </a:buClr>
       <a:buFont typeface="Arial"/>
-      <a:defRPr b="0" i="0" sz="1400" u="none" cap="none" strike="noStrike">
+      <a:defRPr sz="1400" b="0" i="0" u="none" strike="noStrike" cap="none">
         <a:solidFill>
           <a:srgbClr val="000000"/>
         </a:solidFill>
@@ -144,7 +144,7 @@
         <a:sym typeface="Arial"/>
       </a:defRPr>
     </a:lvl5pPr>
-    <a:lvl6pPr lvl="5" marR="0" rtl="0" algn="l">
+    <a:lvl6pPr marR="0" lvl="5" algn="l" rtl="0">
       <a:lnSpc>
         <a:spcPct val="100000"/>
       </a:lnSpc>
@@ -158,7 +158,7 @@
         <a:srgbClr val="000000"/>
       </a:buClr>
       <a:buFont typeface="Arial"/>
-      <a:defRPr b="0" i="0" sz="1400" u="none" cap="none" strike="noStrike">
+      <a:defRPr sz="1400" b="0" i="0" u="none" strike="noStrike" cap="none">
         <a:solidFill>
           <a:srgbClr val="000000"/>
         </a:solidFill>
@@ -168,7 +168,7 @@
         <a:sym typeface="Arial"/>
       </a:defRPr>
     </a:lvl6pPr>
-    <a:lvl7pPr lvl="6" marR="0" rtl="0" algn="l">
+    <a:lvl7pPr marR="0" lvl="6" algn="l" rtl="0">
       <a:lnSpc>
         <a:spcPct val="100000"/>
       </a:lnSpc>
@@ -182,7 +182,7 @@
         <a:srgbClr val="000000"/>
       </a:buClr>
       <a:buFont typeface="Arial"/>
-      <a:defRPr b="0" i="0" sz="1400" u="none" cap="none" strike="noStrike">
+      <a:defRPr sz="1400" b="0" i="0" u="none" strike="noStrike" cap="none">
         <a:solidFill>
           <a:srgbClr val="000000"/>
         </a:solidFill>
@@ -192,7 +192,7 @@
         <a:sym typeface="Arial"/>
       </a:defRPr>
     </a:lvl7pPr>
-    <a:lvl8pPr lvl="7" marR="0" rtl="0" algn="l">
+    <a:lvl8pPr marR="0" lvl="7" algn="l" rtl="0">
       <a:lnSpc>
         <a:spcPct val="100000"/>
       </a:lnSpc>
@@ -206,7 +206,7 @@
         <a:srgbClr val="000000"/>
       </a:buClr>
       <a:buFont typeface="Arial"/>
-      <a:defRPr b="0" i="0" sz="1400" u="none" cap="none" strike="noStrike">
+      <a:defRPr sz="1400" b="0" i="0" u="none" strike="noStrike" cap="none">
         <a:solidFill>
           <a:srgbClr val="000000"/>
         </a:solidFill>
@@ -216,7 +216,7 @@
         <a:sym typeface="Arial"/>
       </a:defRPr>
     </a:lvl8pPr>
-    <a:lvl9pPr lvl="8" marR="0" rtl="0" algn="l">
+    <a:lvl9pPr marR="0" lvl="8" algn="l" rtl="0">
       <a:lnSpc>
         <a:spcPct val="100000"/>
       </a:lnSpc>
@@ -230,7 +230,7 @@
         <a:srgbClr val="000000"/>
       </a:buClr>
       <a:buFont typeface="Arial"/>
-      <a:defRPr b="0" i="0" sz="1400" u="none" cap="none" strike="noStrike">
+      <a:defRPr sz="1400" b="0" i="0" u="none" strike="noStrike" cap="none">
         <a:solidFill>
           <a:srgbClr val="000000"/>
         </a:solidFill>
@@ -243,7 +243,7 @@
   </p:defaultTextStyle>
   <p:extLst>
     <p:ext uri="{EFAFB233-063F-42B5-8137-9DF3F51BA10A}">
-      <p15:sldGuideLst>
+      <p15:sldGuideLst xmlns:p15="http://schemas.microsoft.com/office/powerpoint/2012/main">
         <p15:guide id="1" orient="horz" pos="1620">
           <p15:clr>
             <a:srgbClr val="747775"/>
@@ -260,12 +260,54 @@
 </p:presentation>
 </file>
 
+<file path=ppt/revisionInfo.xml><?xml version="1.0" encoding="utf-8"?>
+<p1510:revInfo xmlns:a="http://schemas.openxmlformats.org/drawingml/2006/main" xmlns:r="http://schemas.openxmlformats.org/officeDocument/2006/relationships" xmlns:p1510="http://schemas.microsoft.com/office/powerpoint/2015/10/main">
+  <p1510:revLst>
+    <p1510:client id="{A23D5DD1-C331-4BB9-96EF-D0B28D870665}" v="1" dt="2026-04-30T21:13:21.632"/>
+  </p1510:revLst>
+</p1510:revInfo>
+</file>
+
+<file path=ppt/changesInfos/changesInfo1.xml><?xml version="1.0" encoding="utf-8"?>
+<pc:chgInfo xmlns:a="http://schemas.openxmlformats.org/drawingml/2006/main" xmlns:r="http://schemas.openxmlformats.org/officeDocument/2006/relationships" xmlns:ac="http://schemas.microsoft.com/office/drawing/2013/main/command" xmlns:pc="http://schemas.microsoft.com/office/powerpoint/2013/main/command">
+  <pc:docChgLst>
+    <pc:chgData name="Cooksey, Amanda (CTR) - REE-ARS" userId="af9940bc-e45f-4f6f-be0b-030ef6402e3d" providerId="ADAL" clId="{26E92B1B-188C-4E22-A183-83CC194A5A67}"/>
+    <pc:docChg chg="modSld">
+      <pc:chgData name="Cooksey, Amanda (CTR) - REE-ARS" userId="af9940bc-e45f-4f6f-be0b-030ef6402e3d" providerId="ADAL" clId="{26E92B1B-188C-4E22-A183-83CC194A5A67}" dt="2026-04-30T21:11:48.946" v="17" actId="20577"/>
+      <pc:docMkLst>
+        <pc:docMk/>
+      </pc:docMkLst>
+      <pc:sldChg chg="modSp mod">
+        <pc:chgData name="Cooksey, Amanda (CTR) - REE-ARS" userId="af9940bc-e45f-4f6f-be0b-030ef6402e3d" providerId="ADAL" clId="{26E92B1B-188C-4E22-A183-83CC194A5A67}" dt="2026-04-30T21:11:48.946" v="17" actId="20577"/>
+        <pc:sldMkLst>
+          <pc:docMk/>
+          <pc:sldMk cId="0" sldId="256"/>
+        </pc:sldMkLst>
+        <pc:spChg chg="mod">
+          <ac:chgData name="Cooksey, Amanda (CTR) - REE-ARS" userId="af9940bc-e45f-4f6f-be0b-030ef6402e3d" providerId="ADAL" clId="{26E92B1B-188C-4E22-A183-83CC194A5A67}" dt="2026-04-30T21:11:48.946" v="17" actId="20577"/>
+          <ac:spMkLst>
+            <pc:docMk/>
+            <pc:sldMk cId="0" sldId="256"/>
+            <ac:spMk id="64" creationId="{00000000-0000-0000-0000-000000000000}"/>
+          </ac:spMkLst>
+        </pc:spChg>
+      </pc:sldChg>
+    </pc:docChg>
+  </pc:docChgLst>
+</pc:chgInfo>
+</file>
+
 <file path=ppt/notesMasters/notesMaster1.xml><?xml version="1.0" encoding="utf-8"?>
-<p:notesMaster xmlns:a="http://schemas.openxmlformats.org/drawingml/2006/main" xmlns:r="http://schemas.openxmlformats.org/officeDocument/2006/relationships" xmlns:mc="http://schemas.openxmlformats.org/markup-compatibility/2006" xmlns:mv="urn:schemas-microsoft-com:mac:vml" xmlns:p="http://schemas.openxmlformats.org/presentationml/2006/main" xmlns:c="http://schemas.openxmlformats.org/drawingml/2006/chart" xmlns:dgm="http://schemas.openxmlformats.org/drawingml/2006/diagram" xmlns:o="urn:schemas-microsoft-com:office:office" xmlns:v="urn:schemas-microsoft-com:vml" xmlns:pvml="urn:schemas-microsoft-com:office:powerpoint" xmlns:com="http://schemas.openxmlformats.org/drawingml/2006/compatibility" xmlns:p14="http://schemas.microsoft.com/office/powerpoint/2010/main" xmlns:p15="http://schemas.microsoft.com/office/powerpoint/2012/main" xmlns:ahyp="http://schemas.microsoft.com/office/drawing/2018/hyperlinkcolor">
+<p:notesMaster xmlns:a="http://schemas.openxmlformats.org/drawingml/2006/main" xmlns:r="http://schemas.openxmlformats.org/officeDocument/2006/relationships" xmlns:p="http://schemas.openxmlformats.org/presentationml/2006/main">
   <p:cSld>
+    <p:bg>
+      <p:bgRef idx="1001">
+        <a:schemeClr val="bg1"/>
+      </p:bgRef>
+    </p:bg>
     <p:spTree>
       <p:nvGrpSpPr>
-        <p:cNvPr id="2" name="Shape 2"/>
+        <p:cNvPr id="1" name="Shape 2"/>
         <p:cNvGrpSpPr/>
         <p:nvPr/>
       </p:nvGrpSpPr>
@@ -280,9 +322,11 @@
       <p:sp>
         <p:nvSpPr>
           <p:cNvPr id="3" name="Google Shape;3;n"/>
-          <p:cNvSpPr/>
+          <p:cNvSpPr>
+            <a:spLocks noGrp="1" noRot="1" noChangeAspect="1"/>
+          </p:cNvSpPr>
           <p:nvPr>
-            <p:ph idx="2" type="sldImg"/>
+            <p:ph type="sldImg" idx="2"/>
           </p:nvPr>
         </p:nvSpPr>
         <p:spPr>
@@ -291,9 +335,13 @@
             <a:ext cx="6096075" cy="3429000"/>
           </a:xfrm>
           <a:custGeom>
-            <a:rect b="b" l="l" r="r" t="t"/>
+            <a:avLst/>
+            <a:gdLst/>
+            <a:ahLst/>
+            <a:cxnLst/>
+            <a:rect l="l" t="t" r="r" b="b"/>
             <a:pathLst>
-              <a:path extrusionOk="0" h="120000" w="120000">
+              <a:path w="120000" h="120000" extrusionOk="0">
                 <a:moveTo>
                   <a:pt x="0" y="0"/>
                 </a:moveTo>
@@ -311,23 +359,25 @@
             </a:pathLst>
           </a:custGeom>
           <a:noFill/>
-          <a:ln cap="flat" cmpd="sng" w="9525">
+          <a:ln w="9525" cap="flat" cmpd="sng">
             <a:solidFill>
               <a:srgbClr val="000000"/>
             </a:solidFill>
             <a:prstDash val="solid"/>
             <a:round/>
-            <a:headEnd len="sm" w="sm" type="none"/>
-            <a:tailEnd len="sm" w="sm" type="none"/>
+            <a:headEnd type="none" w="sm" len="sm"/>
+            <a:tailEnd type="none" w="sm" len="sm"/>
           </a:ln>
         </p:spPr>
       </p:sp>
       <p:sp>
         <p:nvSpPr>
           <p:cNvPr id="4" name="Google Shape;4;n"/>
-          <p:cNvSpPr txBox="1"/>
+          <p:cNvSpPr txBox="1">
+            <a:spLocks noGrp="1"/>
+          </p:cNvSpPr>
           <p:nvPr>
-            <p:ph idx="1" type="body"/>
+            <p:ph type="body" idx="1"/>
           </p:nvPr>
         </p:nvSpPr>
         <p:spPr>
@@ -344,11 +394,11 @@
           </a:ln>
         </p:spPr>
         <p:txBody>
-          <a:bodyPr anchorCtr="0" anchor="t" bIns="91425" lIns="91425" spcFirstLastPara="1" rIns="91425" wrap="square" tIns="91425">
+          <a:bodyPr spcFirstLastPara="1" wrap="square" lIns="91425" tIns="91425" rIns="91425" bIns="91425" anchor="t" anchorCtr="0">
             <a:noAutofit/>
           </a:bodyPr>
           <a:lstStyle>
-            <a:lvl1pPr indent="-298450" lvl="0" marL="457200">
+            <a:lvl1pPr marL="457200" lvl="0" indent="-298450">
               <a:spcBef>
                 <a:spcPts val="0"/>
               </a:spcBef>
@@ -359,7 +409,7 @@
               <a:buChar char="●"/>
               <a:defRPr sz="1100"/>
             </a:lvl1pPr>
-            <a:lvl2pPr indent="-298450" lvl="1" marL="914400">
+            <a:lvl2pPr marL="914400" lvl="1" indent="-298450">
               <a:spcBef>
                 <a:spcPts val="0"/>
               </a:spcBef>
@@ -370,7 +420,7 @@
               <a:buChar char="○"/>
               <a:defRPr sz="1100"/>
             </a:lvl2pPr>
-            <a:lvl3pPr indent="-298450" lvl="2" marL="1371600">
+            <a:lvl3pPr marL="1371600" lvl="2" indent="-298450">
               <a:spcBef>
                 <a:spcPts val="0"/>
               </a:spcBef>
@@ -381,7 +431,7 @@
               <a:buChar char="■"/>
               <a:defRPr sz="1100"/>
             </a:lvl3pPr>
-            <a:lvl4pPr indent="-298450" lvl="3" marL="1828800">
+            <a:lvl4pPr marL="1828800" lvl="3" indent="-298450">
               <a:spcBef>
                 <a:spcPts val="0"/>
               </a:spcBef>
@@ -392,7 +442,7 @@
               <a:buChar char="●"/>
               <a:defRPr sz="1100"/>
             </a:lvl4pPr>
-            <a:lvl5pPr indent="-298450" lvl="4" marL="2286000">
+            <a:lvl5pPr marL="2286000" lvl="4" indent="-298450">
               <a:spcBef>
                 <a:spcPts val="0"/>
               </a:spcBef>
@@ -403,7 +453,7 @@
               <a:buChar char="○"/>
               <a:defRPr sz="1100"/>
             </a:lvl5pPr>
-            <a:lvl6pPr indent="-298450" lvl="5" marL="2743200">
+            <a:lvl6pPr marL="2743200" lvl="5" indent="-298450">
               <a:spcBef>
                 <a:spcPts val="0"/>
               </a:spcBef>
@@ -414,7 +464,7 @@
               <a:buChar char="■"/>
               <a:defRPr sz="1100"/>
             </a:lvl6pPr>
-            <a:lvl7pPr indent="-298450" lvl="6" marL="3200400">
+            <a:lvl7pPr marL="3200400" lvl="6" indent="-298450">
               <a:spcBef>
                 <a:spcPts val="0"/>
               </a:spcBef>
@@ -425,7 +475,7 @@
               <a:buChar char="●"/>
               <a:defRPr sz="1100"/>
             </a:lvl7pPr>
-            <a:lvl8pPr indent="-298450" lvl="7" marL="3657600">
+            <a:lvl8pPr marL="3657600" lvl="7" indent="-298450">
               <a:spcBef>
                 <a:spcPts val="0"/>
               </a:spcBef>
@@ -436,7 +486,7 @@
               <a:buChar char="○"/>
               <a:defRPr sz="1100"/>
             </a:lvl8pPr>
-            <a:lvl9pPr indent="-298450" lvl="8" marL="4114800">
+            <a:lvl9pPr marL="4114800" lvl="8" indent="-298450">
               <a:spcBef>
                 <a:spcPts val="0"/>
               </a:spcBef>
@@ -448,14 +498,16 @@
               <a:defRPr sz="1100"/>
             </a:lvl9pPr>
           </a:lstStyle>
-          <a:p/>
+          <a:p>
+            <a:endParaRPr/>
+          </a:p>
         </p:txBody>
       </p:sp>
     </p:spTree>
   </p:cSld>
-  <p:clrMap accent1="accent1" accent2="accent2" accent3="accent3" accent4="accent4" accent5="accent5" accent6="accent6" bg1="lt1" bg2="dk2" tx1="dk1" tx2="lt2" folHlink="folHlink" hlink="hlink"/>
+  <p:clrMap bg1="lt1" tx1="dk1" bg2="dk2" tx2="lt2" accent1="accent1" accent2="accent2" accent3="accent3" accent4="accent4" accent5="accent5" accent6="accent6" hlink="hlink" folHlink="folHlink"/>
   <p:notesStyle>
-    <a:defPPr lvl="0" marR="0" rtl="0" algn="l">
+    <a:defPPr marR="0" lvl="0" algn="l" rtl="0">
       <a:lnSpc>
         <a:spcPct val="100000"/>
       </a:lnSpc>
@@ -466,7 +518,7 @@
         <a:spcPts val="0"/>
       </a:spcAft>
     </a:defPPr>
-    <a:lvl1pPr lvl="0" marR="0" rtl="0" algn="l">
+    <a:lvl1pPr marR="0" lvl="0" algn="l" rtl="0">
       <a:lnSpc>
         <a:spcPct val="100000"/>
       </a:lnSpc>
@@ -480,7 +532,7 @@
         <a:srgbClr val="000000"/>
       </a:buClr>
       <a:buFont typeface="Arial"/>
-      <a:defRPr b="0" i="0" sz="1400" u="none" cap="none" strike="noStrike">
+      <a:defRPr sz="1400" b="0" i="0" u="none" strike="noStrike" cap="none">
         <a:solidFill>
           <a:srgbClr val="000000"/>
         </a:solidFill>
@@ -490,7 +542,7 @@
         <a:sym typeface="Arial"/>
       </a:defRPr>
     </a:lvl1pPr>
-    <a:lvl2pPr lvl="1" marR="0" rtl="0" algn="l">
+    <a:lvl2pPr marR="0" lvl="1" algn="l" rtl="0">
       <a:lnSpc>
         <a:spcPct val="100000"/>
       </a:lnSpc>
@@ -504,7 +556,7 @@
         <a:srgbClr val="000000"/>
       </a:buClr>
       <a:buFont typeface="Arial"/>
-      <a:defRPr b="0" i="0" sz="1400" u="none" cap="none" strike="noStrike">
+      <a:defRPr sz="1400" b="0" i="0" u="none" strike="noStrike" cap="none">
         <a:solidFill>
           <a:srgbClr val="000000"/>
         </a:solidFill>
@@ -514,7 +566,7 @@
         <a:sym typeface="Arial"/>
       </a:defRPr>
     </a:lvl2pPr>
-    <a:lvl3pPr lvl="2" marR="0" rtl="0" algn="l">
+    <a:lvl3pPr marR="0" lvl="2" algn="l" rtl="0">
       <a:lnSpc>
         <a:spcPct val="100000"/>
       </a:lnSpc>
@@ -528,7 +580,7 @@
         <a:srgbClr val="000000"/>
       </a:buClr>
       <a:buFont typeface="Arial"/>
-      <a:defRPr b="0" i="0" sz="1400" u="none" cap="none" strike="noStrike">
+      <a:defRPr sz="1400" b="0" i="0" u="none" strike="noStrike" cap="none">
         <a:solidFill>
           <a:srgbClr val="000000"/>
         </a:solidFill>
@@ -538,7 +590,7 @@
         <a:sym typeface="Arial"/>
       </a:defRPr>
     </a:lvl3pPr>
-    <a:lvl4pPr lvl="3" marR="0" rtl="0" algn="l">
+    <a:lvl4pPr marR="0" lvl="3" algn="l" rtl="0">
       <a:lnSpc>
         <a:spcPct val="100000"/>
       </a:lnSpc>
@@ -552,7 +604,7 @@
         <a:srgbClr val="000000"/>
       </a:buClr>
       <a:buFont typeface="Arial"/>
-      <a:defRPr b="0" i="0" sz="1400" u="none" cap="none" strike="noStrike">
+      <a:defRPr sz="1400" b="0" i="0" u="none" strike="noStrike" cap="none">
         <a:solidFill>
           <a:srgbClr val="000000"/>
         </a:solidFill>
@@ -562,7 +614,7 @@
         <a:sym typeface="Arial"/>
       </a:defRPr>
     </a:lvl4pPr>
-    <a:lvl5pPr lvl="4" marR="0" rtl="0" algn="l">
+    <a:lvl5pPr marR="0" lvl="4" algn="l" rtl="0">
       <a:lnSpc>
         <a:spcPct val="100000"/>
       </a:lnSpc>
@@ -576,7 +628,7 @@
         <a:srgbClr val="000000"/>
       </a:buClr>
       <a:buFont typeface="Arial"/>
-      <a:defRPr b="0" i="0" sz="1400" u="none" cap="none" strike="noStrike">
+      <a:defRPr sz="1400" b="0" i="0" u="none" strike="noStrike" cap="none">
         <a:solidFill>
           <a:srgbClr val="000000"/>
         </a:solidFill>
@@ -586,7 +638,7 @@
         <a:sym typeface="Arial"/>
       </a:defRPr>
     </a:lvl5pPr>
-    <a:lvl6pPr lvl="5" marR="0" rtl="0" algn="l">
+    <a:lvl6pPr marR="0" lvl="5" algn="l" rtl="0">
       <a:lnSpc>
         <a:spcPct val="100000"/>
       </a:lnSpc>
@@ -600,7 +652,7 @@
         <a:srgbClr val="000000"/>
       </a:buClr>
       <a:buFont typeface="Arial"/>
-      <a:defRPr b="0" i="0" sz="1400" u="none" cap="none" strike="noStrike">
+      <a:defRPr sz="1400" b="0" i="0" u="none" strike="noStrike" cap="none">
         <a:solidFill>
           <a:srgbClr val="000000"/>
         </a:solidFill>
@@ -610,7 +662,7 @@
         <a:sym typeface="Arial"/>
       </a:defRPr>
     </a:lvl6pPr>
-    <a:lvl7pPr lvl="6" marR="0" rtl="0" algn="l">
+    <a:lvl7pPr marR="0" lvl="6" algn="l" rtl="0">
       <a:lnSpc>
         <a:spcPct val="100000"/>
       </a:lnSpc>
@@ -624,7 +676,7 @@
         <a:srgbClr val="000000"/>
       </a:buClr>
       <a:buFont typeface="Arial"/>
-      <a:defRPr b="0" i="0" sz="1400" u="none" cap="none" strike="noStrike">
+      <a:defRPr sz="1400" b="0" i="0" u="none" strike="noStrike" cap="none">
         <a:solidFill>
           <a:srgbClr val="000000"/>
         </a:solidFill>
@@ -634,7 +686,7 @@
         <a:sym typeface="Arial"/>
       </a:defRPr>
     </a:lvl7pPr>
-    <a:lvl8pPr lvl="7" marR="0" rtl="0" algn="l">
+    <a:lvl8pPr marR="0" lvl="7" algn="l" rtl="0">
       <a:lnSpc>
         <a:spcPct val="100000"/>
       </a:lnSpc>
@@ -648,7 +700,7 @@
         <a:srgbClr val="000000"/>
       </a:buClr>
       <a:buFont typeface="Arial"/>
-      <a:defRPr b="0" i="0" sz="1400" u="none" cap="none" strike="noStrike">
+      <a:defRPr sz="1400" b="0" i="0" u="none" strike="noStrike" cap="none">
         <a:solidFill>
           <a:srgbClr val="000000"/>
         </a:solidFill>
@@ -658,7 +710,7 @@
         <a:sym typeface="Arial"/>
       </a:defRPr>
     </a:lvl8pPr>
-    <a:lvl9pPr lvl="8" marR="0" rtl="0" algn="l">
+    <a:lvl9pPr marR="0" lvl="8" algn="l" rtl="0">
       <a:lnSpc>
         <a:spcPct val="100000"/>
       </a:lnSpc>
@@ -672,7 +724,7 @@
         <a:srgbClr val="000000"/>
       </a:buClr>
       <a:buFont typeface="Arial"/>
-      <a:defRPr b="0" i="0" sz="1400" u="none" cap="none" strike="noStrike">
+      <a:defRPr sz="1400" b="0" i="0" u="none" strike="noStrike" cap="none">
         <a:solidFill>
           <a:srgbClr val="000000"/>
         </a:solidFill>
@@ -687,11 +739,11 @@
 </file>
 
 <file path=ppt/notesSlides/notesSlide1.xml><?xml version="1.0" encoding="utf-8"?>
-<p:notes xmlns:a="http://schemas.openxmlformats.org/drawingml/2006/main" xmlns:r="http://schemas.openxmlformats.org/officeDocument/2006/relationships" xmlns:mc="http://schemas.openxmlformats.org/markup-compatibility/2006" xmlns:mv="urn:schemas-microsoft-com:mac:vml" xmlns:p="http://schemas.openxmlformats.org/presentationml/2006/main" xmlns:c="http://schemas.openxmlformats.org/drawingml/2006/chart" xmlns:dgm="http://schemas.openxmlformats.org/drawingml/2006/diagram" xmlns:o="urn:schemas-microsoft-com:office:office" xmlns:v="urn:schemas-microsoft-com:vml" xmlns:pvml="urn:schemas-microsoft-com:office:powerpoint" xmlns:com="http://schemas.openxmlformats.org/drawingml/2006/compatibility" xmlns:p14="http://schemas.microsoft.com/office/powerpoint/2010/main" xmlns:p15="http://schemas.microsoft.com/office/powerpoint/2012/main" xmlns:ahyp="http://schemas.microsoft.com/office/drawing/2018/hyperlinkcolor" showMasterPhAnim="0" showMasterSp="0">
+<p:notes xmlns:a="http://schemas.openxmlformats.org/drawingml/2006/main" xmlns:r="http://schemas.openxmlformats.org/officeDocument/2006/relationships" xmlns:p="http://schemas.openxmlformats.org/presentationml/2006/main" showMasterSp="0" showMasterPhAnim="0">
   <p:cSld>
     <p:spTree>
       <p:nvGrpSpPr>
-        <p:cNvPr id="50" name="Shape 50"/>
+        <p:cNvPr id="1" name="Shape 50"/>
         <p:cNvGrpSpPr/>
         <p:nvPr/>
       </p:nvGrpSpPr>
@@ -706,20 +758,26 @@
       <p:sp>
         <p:nvSpPr>
           <p:cNvPr id="51" name="Google Shape;51;p:notes"/>
-          <p:cNvSpPr/>
+          <p:cNvSpPr>
+            <a:spLocks noGrp="1" noRot="1" noChangeAspect="1"/>
+          </p:cNvSpPr>
           <p:nvPr>
-            <p:ph idx="2" type="sldImg"/>
+            <p:ph type="sldImg" idx="2"/>
           </p:nvPr>
         </p:nvSpPr>
         <p:spPr>
           <a:xfrm>
-            <a:off x="381300" y="685800"/>
-            <a:ext cx="6096075" cy="3429000"/>
+            <a:off x="381000" y="685800"/>
+            <a:ext cx="6096000" cy="3429000"/>
           </a:xfrm>
           <a:custGeom>
-            <a:rect b="b" l="l" r="r" t="t"/>
+            <a:avLst/>
+            <a:gdLst/>
+            <a:ahLst/>
+            <a:cxnLst/>
+            <a:rect l="l" t="t" r="r" b="b"/>
             <a:pathLst>
-              <a:path extrusionOk="0" h="120000" w="120000">
+              <a:path w="120000" h="120000" extrusionOk="0">
                 <a:moveTo>
                   <a:pt x="0" y="0"/>
                 </a:moveTo>
@@ -741,9 +799,11 @@
       <p:sp>
         <p:nvSpPr>
           <p:cNvPr id="52" name="Google Shape;52;p:notes"/>
-          <p:cNvSpPr txBox="1"/>
+          <p:cNvSpPr txBox="1">
+            <a:spLocks noGrp="1"/>
+          </p:cNvSpPr>
           <p:nvPr>
-            <p:ph idx="1" type="body"/>
+            <p:ph type="body" idx="1"/>
           </p:nvPr>
         </p:nvSpPr>
         <p:spPr>
@@ -756,12 +816,12 @@
           </a:prstGeom>
         </p:spPr>
         <p:txBody>
-          <a:bodyPr anchorCtr="0" anchor="t" bIns="91425" lIns="91425" spcFirstLastPara="1" rIns="91425" wrap="square" tIns="91425">
+          <a:bodyPr spcFirstLastPara="1" wrap="square" lIns="91425" tIns="91425" rIns="91425" bIns="91425" anchor="t" anchorCtr="0">
             <a:noAutofit/>
           </a:bodyPr>
           <a:lstStyle/>
           <a:p>
-            <a:pPr indent="0" lvl="0" marL="0" rtl="0" algn="l">
+            <a:pPr marL="0" lvl="0" indent="0" algn="l" rtl="0">
               <a:spcBef>
                 <a:spcPts val="0"/>
               </a:spcBef>
@@ -770,9 +830,6 @@
               </a:spcAft>
               <a:buNone/>
             </a:pPr>
-            <a:r>
-              <a:t/>
-            </a:r>
             <a:endParaRPr/>
           </a:p>
         </p:txBody>
@@ -786,11 +843,11 @@
 </file>
 
 <file path=ppt/slideLayouts/slideLayout1.xml><?xml version="1.0" encoding="utf-8"?>
-<p:sldLayout xmlns:a="http://schemas.openxmlformats.org/drawingml/2006/main" xmlns:r="http://schemas.openxmlformats.org/officeDocument/2006/relationships" xmlns:mc="http://schemas.openxmlformats.org/markup-compatibility/2006" xmlns:mv="urn:schemas-microsoft-com:mac:vml" xmlns:p="http://schemas.openxmlformats.org/presentationml/2006/main" xmlns:c="http://schemas.openxmlformats.org/drawingml/2006/chart" xmlns:dgm="http://schemas.openxmlformats.org/drawingml/2006/diagram" xmlns:o="urn:schemas-microsoft-com:office:office" xmlns:v="urn:schemas-microsoft-com:vml" xmlns:pvml="urn:schemas-microsoft-com:office:powerpoint" xmlns:com="http://schemas.openxmlformats.org/drawingml/2006/compatibility" xmlns:p14="http://schemas.microsoft.com/office/powerpoint/2010/main" xmlns:p15="http://schemas.microsoft.com/office/powerpoint/2012/main" xmlns:ahyp="http://schemas.microsoft.com/office/drawing/2018/hyperlinkcolor" matchingName="Title slide" type="title">
+<p:sldLayout xmlns:a="http://schemas.openxmlformats.org/drawingml/2006/main" xmlns:r="http://schemas.openxmlformats.org/officeDocument/2006/relationships" xmlns:p="http://schemas.openxmlformats.org/presentationml/2006/main" matchingName="Title slide" type="title">
   <p:cSld name="TITLE">
     <p:spTree>
       <p:nvGrpSpPr>
-        <p:cNvPr id="9" name="Shape 9"/>
+        <p:cNvPr id="1" name="Shape 9"/>
         <p:cNvGrpSpPr/>
         <p:nvPr/>
       </p:nvGrpSpPr>
@@ -805,7 +862,9 @@
       <p:sp>
         <p:nvSpPr>
           <p:cNvPr id="10" name="Google Shape;10;p2"/>
-          <p:cNvSpPr txBox="1"/>
+          <p:cNvSpPr txBox="1">
+            <a:spLocks noGrp="1"/>
+          </p:cNvSpPr>
           <p:nvPr>
             <p:ph type="ctrTitle"/>
           </p:nvPr>
@@ -820,7 +879,7 @@
           </a:prstGeom>
         </p:spPr>
         <p:txBody>
-          <a:bodyPr anchorCtr="0" anchor="b" bIns="91425" lIns="91425" spcFirstLastPara="1" rIns="91425" wrap="square" tIns="91425">
+          <a:bodyPr spcFirstLastPara="1" wrap="square" lIns="91425" tIns="91425" rIns="91425" bIns="91425" anchor="b" anchorCtr="0">
             <a:normAutofit/>
           </a:bodyPr>
           <a:lstStyle>
@@ -924,15 +983,19 @@
               <a:defRPr sz="5200"/>
             </a:lvl9pPr>
           </a:lstStyle>
-          <a:p/>
+          <a:p>
+            <a:endParaRPr/>
+          </a:p>
         </p:txBody>
       </p:sp>
       <p:sp>
         <p:nvSpPr>
           <p:cNvPr id="11" name="Google Shape;11;p2"/>
-          <p:cNvSpPr txBox="1"/>
+          <p:cNvSpPr txBox="1">
+            <a:spLocks noGrp="1"/>
+          </p:cNvSpPr>
           <p:nvPr>
-            <p:ph idx="1" type="subTitle"/>
+            <p:ph type="subTitle" idx="1"/>
           </p:nvPr>
         </p:nvSpPr>
         <p:spPr>
@@ -945,7 +1008,7 @@
           </a:prstGeom>
         </p:spPr>
         <p:txBody>
-          <a:bodyPr anchorCtr="0" anchor="t" bIns="91425" lIns="91425" spcFirstLastPara="1" rIns="91425" wrap="square" tIns="91425">
+          <a:bodyPr spcFirstLastPara="1" wrap="square" lIns="91425" tIns="91425" rIns="91425" bIns="91425" anchor="t" anchorCtr="0">
             <a:normAutofit/>
           </a:bodyPr>
           <a:lstStyle>
@@ -1076,15 +1139,19 @@
               <a:defRPr sz="2800"/>
             </a:lvl9pPr>
           </a:lstStyle>
-          <a:p/>
+          <a:p>
+            <a:endParaRPr/>
+          </a:p>
         </p:txBody>
       </p:sp>
       <p:sp>
         <p:nvSpPr>
           <p:cNvPr id="12" name="Google Shape;12;p2"/>
-          <p:cNvSpPr txBox="1"/>
+          <p:cNvSpPr txBox="1">
+            <a:spLocks noGrp="1"/>
+          </p:cNvSpPr>
           <p:nvPr>
-            <p:ph idx="12" type="sldNum"/>
+            <p:ph type="sldNum" idx="12"/>
           </p:nvPr>
         </p:nvSpPr>
         <p:spPr>
@@ -1097,7 +1164,7 @@
           </a:prstGeom>
         </p:spPr>
         <p:txBody>
-          <a:bodyPr anchorCtr="0" anchor="ctr" bIns="91425" lIns="91425" spcFirstLastPara="1" rIns="91425" wrap="square" tIns="91425">
+          <a:bodyPr spcFirstLastPara="1" wrap="square" lIns="91425" tIns="91425" rIns="91425" bIns="91425" anchor="ctr" anchorCtr="0">
             <a:normAutofit/>
           </a:bodyPr>
           <a:lstStyle>
@@ -1139,7 +1206,7 @@
             </a:lvl9pPr>
           </a:lstStyle>
           <a:p>
-            <a:pPr indent="0" lvl="0" marL="0" rtl="0" algn="r">
+            <a:pPr marL="0" lvl="0" indent="0" algn="r" rtl="0">
               <a:spcBef>
                 <a:spcPts val="0"/>
               </a:spcBef>
@@ -1165,11 +1232,11 @@
 </file>
 
 <file path=ppt/slideLayouts/slideLayout10.xml><?xml version="1.0" encoding="utf-8"?>
-<p:sldLayout xmlns:a="http://schemas.openxmlformats.org/drawingml/2006/main" xmlns:r="http://schemas.openxmlformats.org/officeDocument/2006/relationships" xmlns:mc="http://schemas.openxmlformats.org/markup-compatibility/2006" xmlns:mv="urn:schemas-microsoft-com:mac:vml" xmlns:p="http://schemas.openxmlformats.org/presentationml/2006/main" xmlns:c="http://schemas.openxmlformats.org/drawingml/2006/chart" xmlns:dgm="http://schemas.openxmlformats.org/drawingml/2006/diagram" xmlns:o="urn:schemas-microsoft-com:office:office" xmlns:v="urn:schemas-microsoft-com:vml" xmlns:pvml="urn:schemas-microsoft-com:office:powerpoint" xmlns:com="http://schemas.openxmlformats.org/drawingml/2006/compatibility" xmlns:p14="http://schemas.microsoft.com/office/powerpoint/2010/main" xmlns:p15="http://schemas.microsoft.com/office/powerpoint/2012/main" xmlns:ahyp="http://schemas.microsoft.com/office/drawing/2018/hyperlinkcolor" matchingName="Big number">
+<p:sldLayout xmlns:a="http://schemas.openxmlformats.org/drawingml/2006/main" xmlns:r="http://schemas.openxmlformats.org/officeDocument/2006/relationships" xmlns:p="http://schemas.openxmlformats.org/presentationml/2006/main" matchingName="Big number">
   <p:cSld name="BIG_NUMBER">
     <p:spTree>
       <p:nvGrpSpPr>
-        <p:cNvPr id="44" name="Shape 44"/>
+        <p:cNvPr id="1" name="Shape 44"/>
         <p:cNvGrpSpPr/>
         <p:nvPr/>
       </p:nvGrpSpPr>
@@ -1184,9 +1251,11 @@
       <p:sp>
         <p:nvSpPr>
           <p:cNvPr id="45" name="Google Shape;45;p11"/>
-          <p:cNvSpPr txBox="1"/>
+          <p:cNvSpPr txBox="1">
+            <a:spLocks noGrp="1"/>
+          </p:cNvSpPr>
           <p:nvPr>
-            <p:ph hasCustomPrompt="1" type="title"/>
+            <p:ph type="title" hasCustomPrompt="1"/>
           </p:nvPr>
         </p:nvSpPr>
         <p:spPr>
@@ -1199,7 +1268,7 @@
           </a:prstGeom>
         </p:spPr>
         <p:txBody>
-          <a:bodyPr anchorCtr="0" anchor="b" bIns="91425" lIns="91425" spcFirstLastPara="1" rIns="91425" wrap="square" tIns="91425">
+          <a:bodyPr spcFirstLastPara="1" wrap="square" lIns="91425" tIns="91425" rIns="91425" bIns="91425" anchor="b" anchorCtr="0">
             <a:normAutofit/>
           </a:bodyPr>
           <a:lstStyle>
@@ -1313,9 +1382,11 @@
       <p:sp>
         <p:nvSpPr>
           <p:cNvPr id="46" name="Google Shape;46;p11"/>
-          <p:cNvSpPr txBox="1"/>
+          <p:cNvSpPr txBox="1">
+            <a:spLocks noGrp="1"/>
+          </p:cNvSpPr>
           <p:nvPr>
-            <p:ph idx="1" type="body"/>
+            <p:ph type="body" idx="1"/>
           </p:nvPr>
         </p:nvSpPr>
         <p:spPr>
@@ -1328,11 +1399,11 @@
           </a:prstGeom>
         </p:spPr>
         <p:txBody>
-          <a:bodyPr anchorCtr="0" anchor="t" bIns="91425" lIns="91425" spcFirstLastPara="1" rIns="91425" wrap="square" tIns="91425">
+          <a:bodyPr spcFirstLastPara="1" wrap="square" lIns="91425" tIns="91425" rIns="91425" bIns="91425" anchor="t" anchorCtr="0">
             <a:normAutofit/>
           </a:bodyPr>
           <a:lstStyle>
-            <a:lvl1pPr indent="-342900" lvl="0" marL="457200" algn="ctr">
+            <a:lvl1pPr marL="457200" lvl="0" indent="-342900" algn="ctr">
               <a:spcBef>
                 <a:spcPts val="0"/>
               </a:spcBef>
@@ -1343,7 +1414,7 @@
               <a:buChar char="●"/>
               <a:defRPr/>
             </a:lvl1pPr>
-            <a:lvl2pPr indent="-317500" lvl="1" marL="914400" algn="ctr">
+            <a:lvl2pPr marL="914400" lvl="1" indent="-317500" algn="ctr">
               <a:spcBef>
                 <a:spcPts val="0"/>
               </a:spcBef>
@@ -1354,7 +1425,7 @@
               <a:buChar char="○"/>
               <a:defRPr/>
             </a:lvl2pPr>
-            <a:lvl3pPr indent="-317500" lvl="2" marL="1371600" algn="ctr">
+            <a:lvl3pPr marL="1371600" lvl="2" indent="-317500" algn="ctr">
               <a:spcBef>
                 <a:spcPts val="0"/>
               </a:spcBef>
@@ -1365,7 +1436,7 @@
               <a:buChar char="■"/>
               <a:defRPr/>
             </a:lvl3pPr>
-            <a:lvl4pPr indent="-317500" lvl="3" marL="1828800" algn="ctr">
+            <a:lvl4pPr marL="1828800" lvl="3" indent="-317500" algn="ctr">
               <a:spcBef>
                 <a:spcPts val="0"/>
               </a:spcBef>
@@ -1376,7 +1447,7 @@
               <a:buChar char="●"/>
               <a:defRPr/>
             </a:lvl4pPr>
-            <a:lvl5pPr indent="-317500" lvl="4" marL="2286000" algn="ctr">
+            <a:lvl5pPr marL="2286000" lvl="4" indent="-317500" algn="ctr">
               <a:spcBef>
                 <a:spcPts val="0"/>
               </a:spcBef>
@@ -1387,7 +1458,7 @@
               <a:buChar char="○"/>
               <a:defRPr/>
             </a:lvl5pPr>
-            <a:lvl6pPr indent="-317500" lvl="5" marL="2743200" algn="ctr">
+            <a:lvl6pPr marL="2743200" lvl="5" indent="-317500" algn="ctr">
               <a:spcBef>
                 <a:spcPts val="0"/>
               </a:spcBef>
@@ -1398,7 +1469,7 @@
               <a:buChar char="■"/>
               <a:defRPr/>
             </a:lvl6pPr>
-            <a:lvl7pPr indent="-317500" lvl="6" marL="3200400" algn="ctr">
+            <a:lvl7pPr marL="3200400" lvl="6" indent="-317500" algn="ctr">
               <a:spcBef>
                 <a:spcPts val="0"/>
               </a:spcBef>
@@ -1409,7 +1480,7 @@
               <a:buChar char="●"/>
               <a:defRPr/>
             </a:lvl7pPr>
-            <a:lvl8pPr indent="-317500" lvl="7" marL="3657600" algn="ctr">
+            <a:lvl8pPr marL="3657600" lvl="7" indent="-317500" algn="ctr">
               <a:spcBef>
                 <a:spcPts val="0"/>
               </a:spcBef>
@@ -1420,7 +1491,7 @@
               <a:buChar char="○"/>
               <a:defRPr/>
             </a:lvl8pPr>
-            <a:lvl9pPr indent="-317500" lvl="8" marL="4114800" algn="ctr">
+            <a:lvl9pPr marL="4114800" lvl="8" indent="-317500" algn="ctr">
               <a:spcBef>
                 <a:spcPts val="0"/>
               </a:spcBef>
@@ -1432,15 +1503,19 @@
               <a:defRPr/>
             </a:lvl9pPr>
           </a:lstStyle>
-          <a:p/>
+          <a:p>
+            <a:endParaRPr/>
+          </a:p>
         </p:txBody>
       </p:sp>
       <p:sp>
         <p:nvSpPr>
           <p:cNvPr id="47" name="Google Shape;47;p11"/>
-          <p:cNvSpPr txBox="1"/>
+          <p:cNvSpPr txBox="1">
+            <a:spLocks noGrp="1"/>
+          </p:cNvSpPr>
           <p:nvPr>
-            <p:ph idx="12" type="sldNum"/>
+            <p:ph type="sldNum" idx="12"/>
           </p:nvPr>
         </p:nvSpPr>
         <p:spPr>
@@ -1453,7 +1528,7 @@
           </a:prstGeom>
         </p:spPr>
         <p:txBody>
-          <a:bodyPr anchorCtr="0" anchor="ctr" bIns="91425" lIns="91425" spcFirstLastPara="1" rIns="91425" wrap="square" tIns="91425">
+          <a:bodyPr spcFirstLastPara="1" wrap="square" lIns="91425" tIns="91425" rIns="91425" bIns="91425" anchor="ctr" anchorCtr="0">
             <a:normAutofit/>
           </a:bodyPr>
           <a:lstStyle>
@@ -1495,7 +1570,7 @@
             </a:lvl9pPr>
           </a:lstStyle>
           <a:p>
-            <a:pPr indent="0" lvl="0" marL="0" rtl="0" algn="r">
+            <a:pPr marL="0" lvl="0" indent="0" algn="r" rtl="0">
               <a:spcBef>
                 <a:spcPts val="0"/>
               </a:spcBef>
@@ -1521,11 +1596,11 @@
 </file>
 
 <file path=ppt/slideLayouts/slideLayout11.xml><?xml version="1.0" encoding="utf-8"?>
-<p:sldLayout xmlns:a="http://schemas.openxmlformats.org/drawingml/2006/main" xmlns:r="http://schemas.openxmlformats.org/officeDocument/2006/relationships" xmlns:mc="http://schemas.openxmlformats.org/markup-compatibility/2006" xmlns:mv="urn:schemas-microsoft-com:mac:vml" xmlns:p="http://schemas.openxmlformats.org/presentationml/2006/main" xmlns:c="http://schemas.openxmlformats.org/drawingml/2006/chart" xmlns:dgm="http://schemas.openxmlformats.org/drawingml/2006/diagram" xmlns:o="urn:schemas-microsoft-com:office:office" xmlns:v="urn:schemas-microsoft-com:vml" xmlns:pvml="urn:schemas-microsoft-com:office:powerpoint" xmlns:com="http://schemas.openxmlformats.org/drawingml/2006/compatibility" xmlns:p14="http://schemas.microsoft.com/office/powerpoint/2010/main" xmlns:p15="http://schemas.microsoft.com/office/powerpoint/2012/main" xmlns:ahyp="http://schemas.microsoft.com/office/drawing/2018/hyperlinkcolor" matchingName="Blank" type="blank">
+<p:sldLayout xmlns:a="http://schemas.openxmlformats.org/drawingml/2006/main" xmlns:r="http://schemas.openxmlformats.org/officeDocument/2006/relationships" xmlns:p="http://schemas.openxmlformats.org/presentationml/2006/main" matchingName="Blank" type="blank">
   <p:cSld name="BLANK">
     <p:spTree>
       <p:nvGrpSpPr>
-        <p:cNvPr id="48" name="Shape 48"/>
+        <p:cNvPr id="1" name="Shape 48"/>
         <p:cNvGrpSpPr/>
         <p:nvPr/>
       </p:nvGrpSpPr>
@@ -1540,9 +1615,11 @@
       <p:sp>
         <p:nvSpPr>
           <p:cNvPr id="49" name="Google Shape;49;p12"/>
-          <p:cNvSpPr txBox="1"/>
+          <p:cNvSpPr txBox="1">
+            <a:spLocks noGrp="1"/>
+          </p:cNvSpPr>
           <p:nvPr>
-            <p:ph idx="12" type="sldNum"/>
+            <p:ph type="sldNum" idx="12"/>
           </p:nvPr>
         </p:nvSpPr>
         <p:spPr>
@@ -1555,7 +1632,7 @@
           </a:prstGeom>
         </p:spPr>
         <p:txBody>
-          <a:bodyPr anchorCtr="0" anchor="ctr" bIns="91425" lIns="91425" spcFirstLastPara="1" rIns="91425" wrap="square" tIns="91425">
+          <a:bodyPr spcFirstLastPara="1" wrap="square" lIns="91425" tIns="91425" rIns="91425" bIns="91425" anchor="ctr" anchorCtr="0">
             <a:normAutofit/>
           </a:bodyPr>
           <a:lstStyle>
@@ -1597,7 +1674,7 @@
             </a:lvl9pPr>
           </a:lstStyle>
           <a:p>
-            <a:pPr indent="0" lvl="0" marL="0" rtl="0" algn="r">
+            <a:pPr marL="0" lvl="0" indent="0" algn="r" rtl="0">
               <a:spcBef>
                 <a:spcPts val="0"/>
               </a:spcBef>
@@ -1623,11 +1700,11 @@
 </file>
 
 <file path=ppt/slideLayouts/slideLayout2.xml><?xml version="1.0" encoding="utf-8"?>
-<p:sldLayout xmlns:a="http://schemas.openxmlformats.org/drawingml/2006/main" xmlns:r="http://schemas.openxmlformats.org/officeDocument/2006/relationships" xmlns:mc="http://schemas.openxmlformats.org/markup-compatibility/2006" xmlns:mv="urn:schemas-microsoft-com:mac:vml" xmlns:p="http://schemas.openxmlformats.org/presentationml/2006/main" xmlns:c="http://schemas.openxmlformats.org/drawingml/2006/chart" xmlns:dgm="http://schemas.openxmlformats.org/drawingml/2006/diagram" xmlns:o="urn:schemas-microsoft-com:office:office" xmlns:v="urn:schemas-microsoft-com:vml" xmlns:pvml="urn:schemas-microsoft-com:office:powerpoint" xmlns:com="http://schemas.openxmlformats.org/drawingml/2006/compatibility" xmlns:p14="http://schemas.microsoft.com/office/powerpoint/2010/main" xmlns:p15="http://schemas.microsoft.com/office/powerpoint/2012/main" xmlns:ahyp="http://schemas.microsoft.com/office/drawing/2018/hyperlinkcolor" matchingName="Section header" type="secHead">
+<p:sldLayout xmlns:a="http://schemas.openxmlformats.org/drawingml/2006/main" xmlns:r="http://schemas.openxmlformats.org/officeDocument/2006/relationships" xmlns:p="http://schemas.openxmlformats.org/presentationml/2006/main" matchingName="Section header" type="secHead">
   <p:cSld name="SECTION_HEADER">
     <p:spTree>
       <p:nvGrpSpPr>
-        <p:cNvPr id="13" name="Shape 13"/>
+        <p:cNvPr id="1" name="Shape 13"/>
         <p:cNvGrpSpPr/>
         <p:nvPr/>
       </p:nvGrpSpPr>
@@ -1642,7 +1719,9 @@
       <p:sp>
         <p:nvSpPr>
           <p:cNvPr id="14" name="Google Shape;14;p3"/>
-          <p:cNvSpPr txBox="1"/>
+          <p:cNvSpPr txBox="1">
+            <a:spLocks noGrp="1"/>
+          </p:cNvSpPr>
           <p:nvPr>
             <p:ph type="title"/>
           </p:nvPr>
@@ -1657,7 +1736,7 @@
           </a:prstGeom>
         </p:spPr>
         <p:txBody>
-          <a:bodyPr anchorCtr="0" anchor="ctr" bIns="91425" lIns="91425" spcFirstLastPara="1" rIns="91425" wrap="square" tIns="91425">
+          <a:bodyPr spcFirstLastPara="1" wrap="square" lIns="91425" tIns="91425" rIns="91425" bIns="91425" anchor="ctr" anchorCtr="0">
             <a:normAutofit/>
           </a:bodyPr>
           <a:lstStyle>
@@ -1761,15 +1840,19 @@
               <a:defRPr sz="3600"/>
             </a:lvl9pPr>
           </a:lstStyle>
-          <a:p/>
+          <a:p>
+            <a:endParaRPr/>
+          </a:p>
         </p:txBody>
       </p:sp>
       <p:sp>
         <p:nvSpPr>
           <p:cNvPr id="15" name="Google Shape;15;p3"/>
-          <p:cNvSpPr txBox="1"/>
+          <p:cNvSpPr txBox="1">
+            <a:spLocks noGrp="1"/>
+          </p:cNvSpPr>
           <p:nvPr>
-            <p:ph idx="12" type="sldNum"/>
+            <p:ph type="sldNum" idx="12"/>
           </p:nvPr>
         </p:nvSpPr>
         <p:spPr>
@@ -1782,7 +1865,7 @@
           </a:prstGeom>
         </p:spPr>
         <p:txBody>
-          <a:bodyPr anchorCtr="0" anchor="ctr" bIns="91425" lIns="91425" spcFirstLastPara="1" rIns="91425" wrap="square" tIns="91425">
+          <a:bodyPr spcFirstLastPara="1" wrap="square" lIns="91425" tIns="91425" rIns="91425" bIns="91425" anchor="ctr" anchorCtr="0">
             <a:normAutofit/>
           </a:bodyPr>
           <a:lstStyle>
@@ -1824,7 +1907,7 @@
             </a:lvl9pPr>
           </a:lstStyle>
           <a:p>
-            <a:pPr indent="0" lvl="0" marL="0" rtl="0" algn="r">
+            <a:pPr marL="0" lvl="0" indent="0" algn="r" rtl="0">
               <a:spcBef>
                 <a:spcPts val="0"/>
               </a:spcBef>
@@ -1850,11 +1933,11 @@
 </file>
 
 <file path=ppt/slideLayouts/slideLayout3.xml><?xml version="1.0" encoding="utf-8"?>
-<p:sldLayout xmlns:a="http://schemas.openxmlformats.org/drawingml/2006/main" xmlns:r="http://schemas.openxmlformats.org/officeDocument/2006/relationships" xmlns:mc="http://schemas.openxmlformats.org/markup-compatibility/2006" xmlns:mv="urn:schemas-microsoft-com:mac:vml" xmlns:p="http://schemas.openxmlformats.org/presentationml/2006/main" xmlns:c="http://schemas.openxmlformats.org/drawingml/2006/chart" xmlns:dgm="http://schemas.openxmlformats.org/drawingml/2006/diagram" xmlns:o="urn:schemas-microsoft-com:office:office" xmlns:v="urn:schemas-microsoft-com:vml" xmlns:pvml="urn:schemas-microsoft-com:office:powerpoint" xmlns:com="http://schemas.openxmlformats.org/drawingml/2006/compatibility" xmlns:p14="http://schemas.microsoft.com/office/powerpoint/2010/main" xmlns:p15="http://schemas.microsoft.com/office/powerpoint/2012/main" xmlns:ahyp="http://schemas.microsoft.com/office/drawing/2018/hyperlinkcolor" matchingName="Title and body" type="tx">
+<p:sldLayout xmlns:a="http://schemas.openxmlformats.org/drawingml/2006/main" xmlns:r="http://schemas.openxmlformats.org/officeDocument/2006/relationships" xmlns:p="http://schemas.openxmlformats.org/presentationml/2006/main" matchingName="Title and body" type="tx">
   <p:cSld name="TITLE_AND_BODY">
     <p:spTree>
       <p:nvGrpSpPr>
-        <p:cNvPr id="16" name="Shape 16"/>
+        <p:cNvPr id="1" name="Shape 16"/>
         <p:cNvGrpSpPr/>
         <p:nvPr/>
       </p:nvGrpSpPr>
@@ -1869,7 +1952,9 @@
       <p:sp>
         <p:nvSpPr>
           <p:cNvPr id="17" name="Google Shape;17;p4"/>
-          <p:cNvSpPr txBox="1"/>
+          <p:cNvSpPr txBox="1">
+            <a:spLocks noGrp="1"/>
+          </p:cNvSpPr>
           <p:nvPr>
             <p:ph type="title"/>
           </p:nvPr>
@@ -1884,7 +1969,7 @@
           </a:prstGeom>
         </p:spPr>
         <p:txBody>
-          <a:bodyPr anchorCtr="0" anchor="t" bIns="91425" lIns="91425" spcFirstLastPara="1" rIns="91425" wrap="square" tIns="91425">
+          <a:bodyPr spcFirstLastPara="1" wrap="square" lIns="91425" tIns="91425" rIns="91425" bIns="91425" anchor="t" anchorCtr="0">
             <a:normAutofit/>
           </a:bodyPr>
           <a:lstStyle>
@@ -1988,15 +2073,19 @@
               <a:defRPr/>
             </a:lvl9pPr>
           </a:lstStyle>
-          <a:p/>
+          <a:p>
+            <a:endParaRPr/>
+          </a:p>
         </p:txBody>
       </p:sp>
       <p:sp>
         <p:nvSpPr>
           <p:cNvPr id="18" name="Google Shape;18;p4"/>
-          <p:cNvSpPr txBox="1"/>
+          <p:cNvSpPr txBox="1">
+            <a:spLocks noGrp="1"/>
+          </p:cNvSpPr>
           <p:nvPr>
-            <p:ph idx="1" type="body"/>
+            <p:ph type="body" idx="1"/>
           </p:nvPr>
         </p:nvSpPr>
         <p:spPr>
@@ -2009,11 +2098,11 @@
           </a:prstGeom>
         </p:spPr>
         <p:txBody>
-          <a:bodyPr anchorCtr="0" anchor="t" bIns="91425" lIns="91425" spcFirstLastPara="1" rIns="91425" wrap="square" tIns="91425">
+          <a:bodyPr spcFirstLastPara="1" wrap="square" lIns="91425" tIns="91425" rIns="91425" bIns="91425" anchor="t" anchorCtr="0">
             <a:normAutofit/>
           </a:bodyPr>
           <a:lstStyle>
-            <a:lvl1pPr indent="-342900" lvl="0" marL="457200">
+            <a:lvl1pPr marL="457200" lvl="0" indent="-342900">
               <a:spcBef>
                 <a:spcPts val="0"/>
               </a:spcBef>
@@ -2024,7 +2113,7 @@
               <a:buChar char="●"/>
               <a:defRPr/>
             </a:lvl1pPr>
-            <a:lvl2pPr indent="-317500" lvl="1" marL="914400">
+            <a:lvl2pPr marL="914400" lvl="1" indent="-317500">
               <a:spcBef>
                 <a:spcPts val="0"/>
               </a:spcBef>
@@ -2035,7 +2124,7 @@
               <a:buChar char="○"/>
               <a:defRPr/>
             </a:lvl2pPr>
-            <a:lvl3pPr indent="-317500" lvl="2" marL="1371600">
+            <a:lvl3pPr marL="1371600" lvl="2" indent="-317500">
               <a:spcBef>
                 <a:spcPts val="0"/>
               </a:spcBef>
@@ -2046,7 +2135,7 @@
               <a:buChar char="■"/>
               <a:defRPr/>
             </a:lvl3pPr>
-            <a:lvl4pPr indent="-317500" lvl="3" marL="1828800">
+            <a:lvl4pPr marL="1828800" lvl="3" indent="-317500">
               <a:spcBef>
                 <a:spcPts val="0"/>
               </a:spcBef>
@@ -2057,7 +2146,7 @@
               <a:buChar char="●"/>
               <a:defRPr/>
             </a:lvl4pPr>
-            <a:lvl5pPr indent="-317500" lvl="4" marL="2286000">
+            <a:lvl5pPr marL="2286000" lvl="4" indent="-317500">
               <a:spcBef>
                 <a:spcPts val="0"/>
               </a:spcBef>
@@ -2068,7 +2157,7 @@
               <a:buChar char="○"/>
               <a:defRPr/>
             </a:lvl5pPr>
-            <a:lvl6pPr indent="-317500" lvl="5" marL="2743200">
+            <a:lvl6pPr marL="2743200" lvl="5" indent="-317500">
               <a:spcBef>
                 <a:spcPts val="0"/>
               </a:spcBef>
@@ -2079,7 +2168,7 @@
               <a:buChar char="■"/>
               <a:defRPr/>
             </a:lvl6pPr>
-            <a:lvl7pPr indent="-317500" lvl="6" marL="3200400">
+            <a:lvl7pPr marL="3200400" lvl="6" indent="-317500">
               <a:spcBef>
                 <a:spcPts val="0"/>
               </a:spcBef>
@@ -2090,7 +2179,7 @@
               <a:buChar char="●"/>
               <a:defRPr/>
             </a:lvl7pPr>
-            <a:lvl8pPr indent="-317500" lvl="7" marL="3657600">
+            <a:lvl8pPr marL="3657600" lvl="7" indent="-317500">
               <a:spcBef>
                 <a:spcPts val="0"/>
               </a:spcBef>
@@ -2101,7 +2190,7 @@
               <a:buChar char="○"/>
               <a:defRPr/>
             </a:lvl8pPr>
-            <a:lvl9pPr indent="-317500" lvl="8" marL="4114800">
+            <a:lvl9pPr marL="4114800" lvl="8" indent="-317500">
               <a:spcBef>
                 <a:spcPts val="0"/>
               </a:spcBef>
@@ -2113,15 +2202,19 @@
               <a:defRPr/>
             </a:lvl9pPr>
           </a:lstStyle>
-          <a:p/>
+          <a:p>
+            <a:endParaRPr/>
+          </a:p>
         </p:txBody>
       </p:sp>
       <p:sp>
         <p:nvSpPr>
           <p:cNvPr id="19" name="Google Shape;19;p4"/>
-          <p:cNvSpPr txBox="1"/>
+          <p:cNvSpPr txBox="1">
+            <a:spLocks noGrp="1"/>
+          </p:cNvSpPr>
           <p:nvPr>
-            <p:ph idx="12" type="sldNum"/>
+            <p:ph type="sldNum" idx="12"/>
           </p:nvPr>
         </p:nvSpPr>
         <p:spPr>
@@ -2134,7 +2227,7 @@
           </a:prstGeom>
         </p:spPr>
         <p:txBody>
-          <a:bodyPr anchorCtr="0" anchor="ctr" bIns="91425" lIns="91425" spcFirstLastPara="1" rIns="91425" wrap="square" tIns="91425">
+          <a:bodyPr spcFirstLastPara="1" wrap="square" lIns="91425" tIns="91425" rIns="91425" bIns="91425" anchor="ctr" anchorCtr="0">
             <a:normAutofit/>
           </a:bodyPr>
           <a:lstStyle>
@@ -2176,7 +2269,7 @@
             </a:lvl9pPr>
           </a:lstStyle>
           <a:p>
-            <a:pPr indent="0" lvl="0" marL="0" rtl="0" algn="r">
+            <a:pPr marL="0" lvl="0" indent="0" algn="r" rtl="0">
               <a:spcBef>
                 <a:spcPts val="0"/>
               </a:spcBef>
@@ -2202,11 +2295,11 @@
 </file>
 
 <file path=ppt/slideLayouts/slideLayout4.xml><?xml version="1.0" encoding="utf-8"?>
-<p:sldLayout xmlns:a="http://schemas.openxmlformats.org/drawingml/2006/main" xmlns:r="http://schemas.openxmlformats.org/officeDocument/2006/relationships" xmlns:mc="http://schemas.openxmlformats.org/markup-compatibility/2006" xmlns:mv="urn:schemas-microsoft-com:mac:vml" xmlns:p="http://schemas.openxmlformats.org/presentationml/2006/main" xmlns:c="http://schemas.openxmlformats.org/drawingml/2006/chart" xmlns:dgm="http://schemas.openxmlformats.org/drawingml/2006/diagram" xmlns:o="urn:schemas-microsoft-com:office:office" xmlns:v="urn:schemas-microsoft-com:vml" xmlns:pvml="urn:schemas-microsoft-com:office:powerpoint" xmlns:com="http://schemas.openxmlformats.org/drawingml/2006/compatibility" xmlns:p14="http://schemas.microsoft.com/office/powerpoint/2010/main" xmlns:p15="http://schemas.microsoft.com/office/powerpoint/2012/main" xmlns:ahyp="http://schemas.microsoft.com/office/drawing/2018/hyperlinkcolor" matchingName="Title and two columns" type="twoColTx">
+<p:sldLayout xmlns:a="http://schemas.openxmlformats.org/drawingml/2006/main" xmlns:r="http://schemas.openxmlformats.org/officeDocument/2006/relationships" xmlns:p="http://schemas.openxmlformats.org/presentationml/2006/main" matchingName="Title and two columns" type="twoColTx">
   <p:cSld name="TITLE_AND_TWO_COLUMNS">
     <p:spTree>
       <p:nvGrpSpPr>
-        <p:cNvPr id="20" name="Shape 20"/>
+        <p:cNvPr id="1" name="Shape 20"/>
         <p:cNvGrpSpPr/>
         <p:nvPr/>
       </p:nvGrpSpPr>
@@ -2221,7 +2314,9 @@
       <p:sp>
         <p:nvSpPr>
           <p:cNvPr id="21" name="Google Shape;21;p5"/>
-          <p:cNvSpPr txBox="1"/>
+          <p:cNvSpPr txBox="1">
+            <a:spLocks noGrp="1"/>
+          </p:cNvSpPr>
           <p:nvPr>
             <p:ph type="title"/>
           </p:nvPr>
@@ -2236,7 +2331,7 @@
           </a:prstGeom>
         </p:spPr>
         <p:txBody>
-          <a:bodyPr anchorCtr="0" anchor="t" bIns="91425" lIns="91425" spcFirstLastPara="1" rIns="91425" wrap="square" tIns="91425">
+          <a:bodyPr spcFirstLastPara="1" wrap="square" lIns="91425" tIns="91425" rIns="91425" bIns="91425" anchor="t" anchorCtr="0">
             <a:normAutofit/>
           </a:bodyPr>
           <a:lstStyle>
@@ -2340,15 +2435,19 @@
               <a:defRPr/>
             </a:lvl9pPr>
           </a:lstStyle>
-          <a:p/>
+          <a:p>
+            <a:endParaRPr/>
+          </a:p>
         </p:txBody>
       </p:sp>
       <p:sp>
         <p:nvSpPr>
           <p:cNvPr id="22" name="Google Shape;22;p5"/>
-          <p:cNvSpPr txBox="1"/>
+          <p:cNvSpPr txBox="1">
+            <a:spLocks noGrp="1"/>
+          </p:cNvSpPr>
           <p:nvPr>
-            <p:ph idx="1" type="body"/>
+            <p:ph type="body" idx="1"/>
           </p:nvPr>
         </p:nvSpPr>
         <p:spPr>
@@ -2361,11 +2460,11 @@
           </a:prstGeom>
         </p:spPr>
         <p:txBody>
-          <a:bodyPr anchorCtr="0" anchor="t" bIns="91425" lIns="91425" spcFirstLastPara="1" rIns="91425" wrap="square" tIns="91425">
+          <a:bodyPr spcFirstLastPara="1" wrap="square" lIns="91425" tIns="91425" rIns="91425" bIns="91425" anchor="t" anchorCtr="0">
             <a:normAutofit/>
           </a:bodyPr>
           <a:lstStyle>
-            <a:lvl1pPr indent="-317500" lvl="0" marL="457200">
+            <a:lvl1pPr marL="457200" lvl="0" indent="-317500">
               <a:spcBef>
                 <a:spcPts val="0"/>
               </a:spcBef>
@@ -2376,7 +2475,7 @@
               <a:buChar char="●"/>
               <a:defRPr sz="1400"/>
             </a:lvl1pPr>
-            <a:lvl2pPr indent="-304800" lvl="1" marL="914400">
+            <a:lvl2pPr marL="914400" lvl="1" indent="-304800">
               <a:spcBef>
                 <a:spcPts val="0"/>
               </a:spcBef>
@@ -2387,7 +2486,7 @@
               <a:buChar char="○"/>
               <a:defRPr sz="1200"/>
             </a:lvl2pPr>
-            <a:lvl3pPr indent="-304800" lvl="2" marL="1371600">
+            <a:lvl3pPr marL="1371600" lvl="2" indent="-304800">
               <a:spcBef>
                 <a:spcPts val="0"/>
               </a:spcBef>
@@ -2398,7 +2497,7 @@
               <a:buChar char="■"/>
               <a:defRPr sz="1200"/>
             </a:lvl3pPr>
-            <a:lvl4pPr indent="-304800" lvl="3" marL="1828800">
+            <a:lvl4pPr marL="1828800" lvl="3" indent="-304800">
               <a:spcBef>
                 <a:spcPts val="0"/>
               </a:spcBef>
@@ -2409,7 +2508,7 @@
               <a:buChar char="●"/>
               <a:defRPr sz="1200"/>
             </a:lvl4pPr>
-            <a:lvl5pPr indent="-304800" lvl="4" marL="2286000">
+            <a:lvl5pPr marL="2286000" lvl="4" indent="-304800">
               <a:spcBef>
                 <a:spcPts val="0"/>
               </a:spcBef>
@@ -2420,7 +2519,7 @@
               <a:buChar char="○"/>
               <a:defRPr sz="1200"/>
             </a:lvl5pPr>
-            <a:lvl6pPr indent="-304800" lvl="5" marL="2743200">
+            <a:lvl6pPr marL="2743200" lvl="5" indent="-304800">
               <a:spcBef>
                 <a:spcPts val="0"/>
               </a:spcBef>
@@ -2431,7 +2530,7 @@
               <a:buChar char="■"/>
               <a:defRPr sz="1200"/>
             </a:lvl6pPr>
-            <a:lvl7pPr indent="-304800" lvl="6" marL="3200400">
+            <a:lvl7pPr marL="3200400" lvl="6" indent="-304800">
               <a:spcBef>
                 <a:spcPts val="0"/>
               </a:spcBef>
@@ -2442,7 +2541,7 @@
               <a:buChar char="●"/>
               <a:defRPr sz="1200"/>
             </a:lvl7pPr>
-            <a:lvl8pPr indent="-304800" lvl="7" marL="3657600">
+            <a:lvl8pPr marL="3657600" lvl="7" indent="-304800">
               <a:spcBef>
                 <a:spcPts val="0"/>
               </a:spcBef>
@@ -2453,7 +2552,7 @@
               <a:buChar char="○"/>
               <a:defRPr sz="1200"/>
             </a:lvl8pPr>
-            <a:lvl9pPr indent="-304800" lvl="8" marL="4114800">
+            <a:lvl9pPr marL="4114800" lvl="8" indent="-304800">
               <a:spcBef>
                 <a:spcPts val="0"/>
               </a:spcBef>
@@ -2465,15 +2564,19 @@
               <a:defRPr sz="1200"/>
             </a:lvl9pPr>
           </a:lstStyle>
-          <a:p/>
+          <a:p>
+            <a:endParaRPr/>
+          </a:p>
         </p:txBody>
       </p:sp>
       <p:sp>
         <p:nvSpPr>
           <p:cNvPr id="23" name="Google Shape;23;p5"/>
-          <p:cNvSpPr txBox="1"/>
+          <p:cNvSpPr txBox="1">
+            <a:spLocks noGrp="1"/>
+          </p:cNvSpPr>
           <p:nvPr>
-            <p:ph idx="2" type="body"/>
+            <p:ph type="body" idx="2"/>
           </p:nvPr>
         </p:nvSpPr>
         <p:spPr>
@@ -2486,11 +2589,11 @@
           </a:prstGeom>
         </p:spPr>
         <p:txBody>
-          <a:bodyPr anchorCtr="0" anchor="t" bIns="91425" lIns="91425" spcFirstLastPara="1" rIns="91425" wrap="square" tIns="91425">
+          <a:bodyPr spcFirstLastPara="1" wrap="square" lIns="91425" tIns="91425" rIns="91425" bIns="91425" anchor="t" anchorCtr="0">
             <a:normAutofit/>
           </a:bodyPr>
           <a:lstStyle>
-            <a:lvl1pPr indent="-317500" lvl="0" marL="457200">
+            <a:lvl1pPr marL="457200" lvl="0" indent="-317500">
               <a:spcBef>
                 <a:spcPts val="0"/>
               </a:spcBef>
@@ -2501,7 +2604,7 @@
               <a:buChar char="●"/>
               <a:defRPr sz="1400"/>
             </a:lvl1pPr>
-            <a:lvl2pPr indent="-304800" lvl="1" marL="914400">
+            <a:lvl2pPr marL="914400" lvl="1" indent="-304800">
               <a:spcBef>
                 <a:spcPts val="0"/>
               </a:spcBef>
@@ -2512,7 +2615,7 @@
               <a:buChar char="○"/>
               <a:defRPr sz="1200"/>
             </a:lvl2pPr>
-            <a:lvl3pPr indent="-304800" lvl="2" marL="1371600">
+            <a:lvl3pPr marL="1371600" lvl="2" indent="-304800">
               <a:spcBef>
                 <a:spcPts val="0"/>
               </a:spcBef>
@@ -2523,7 +2626,7 @@
               <a:buChar char="■"/>
               <a:defRPr sz="1200"/>
             </a:lvl3pPr>
-            <a:lvl4pPr indent="-304800" lvl="3" marL="1828800">
+            <a:lvl4pPr marL="1828800" lvl="3" indent="-304800">
               <a:spcBef>
                 <a:spcPts val="0"/>
               </a:spcBef>
@@ -2534,7 +2637,7 @@
               <a:buChar char="●"/>
               <a:defRPr sz="1200"/>
             </a:lvl4pPr>
-            <a:lvl5pPr indent="-304800" lvl="4" marL="2286000">
+            <a:lvl5pPr marL="2286000" lvl="4" indent="-304800">
               <a:spcBef>
                 <a:spcPts val="0"/>
               </a:spcBef>
@@ -2545,7 +2648,7 @@
               <a:buChar char="○"/>
               <a:defRPr sz="1200"/>
             </a:lvl5pPr>
-            <a:lvl6pPr indent="-304800" lvl="5" marL="2743200">
+            <a:lvl6pPr marL="2743200" lvl="5" indent="-304800">
               <a:spcBef>
                 <a:spcPts val="0"/>
               </a:spcBef>
@@ -2556,7 +2659,7 @@
               <a:buChar char="■"/>
               <a:defRPr sz="1200"/>
             </a:lvl6pPr>
-            <a:lvl7pPr indent="-304800" lvl="6" marL="3200400">
+            <a:lvl7pPr marL="3200400" lvl="6" indent="-304800">
               <a:spcBef>
                 <a:spcPts val="0"/>
               </a:spcBef>
@@ -2567,7 +2670,7 @@
               <a:buChar char="●"/>
               <a:defRPr sz="1200"/>
             </a:lvl7pPr>
-            <a:lvl8pPr indent="-304800" lvl="7" marL="3657600">
+            <a:lvl8pPr marL="3657600" lvl="7" indent="-304800">
               <a:spcBef>
                 <a:spcPts val="0"/>
               </a:spcBef>
@@ -2578,7 +2681,7 @@
               <a:buChar char="○"/>
               <a:defRPr sz="1200"/>
             </a:lvl8pPr>
-            <a:lvl9pPr indent="-304800" lvl="8" marL="4114800">
+            <a:lvl9pPr marL="4114800" lvl="8" indent="-304800">
               <a:spcBef>
                 <a:spcPts val="0"/>
               </a:spcBef>
@@ -2590,15 +2693,19 @@
               <a:defRPr sz="1200"/>
             </a:lvl9pPr>
           </a:lstStyle>
-          <a:p/>
+          <a:p>
+            <a:endParaRPr/>
+          </a:p>
         </p:txBody>
       </p:sp>
       <p:sp>
         <p:nvSpPr>
           <p:cNvPr id="24" name="Google Shape;24;p5"/>
-          <p:cNvSpPr txBox="1"/>
+          <p:cNvSpPr txBox="1">
+            <a:spLocks noGrp="1"/>
+          </p:cNvSpPr>
           <p:nvPr>
-            <p:ph idx="12" type="sldNum"/>
+            <p:ph type="sldNum" idx="12"/>
           </p:nvPr>
         </p:nvSpPr>
         <p:spPr>
@@ -2611,7 +2718,7 @@
           </a:prstGeom>
         </p:spPr>
         <p:txBody>
-          <a:bodyPr anchorCtr="0" anchor="ctr" bIns="91425" lIns="91425" spcFirstLastPara="1" rIns="91425" wrap="square" tIns="91425">
+          <a:bodyPr spcFirstLastPara="1" wrap="square" lIns="91425" tIns="91425" rIns="91425" bIns="91425" anchor="ctr" anchorCtr="0">
             <a:normAutofit/>
           </a:bodyPr>
           <a:lstStyle>
@@ -2653,7 +2760,7 @@
             </a:lvl9pPr>
           </a:lstStyle>
           <a:p>
-            <a:pPr indent="0" lvl="0" marL="0" rtl="0" algn="r">
+            <a:pPr marL="0" lvl="0" indent="0" algn="r" rtl="0">
               <a:spcBef>
                 <a:spcPts val="0"/>
               </a:spcBef>
@@ -2679,11 +2786,11 @@
 </file>
 
 <file path=ppt/slideLayouts/slideLayout5.xml><?xml version="1.0" encoding="utf-8"?>
-<p:sldLayout xmlns:a="http://schemas.openxmlformats.org/drawingml/2006/main" xmlns:r="http://schemas.openxmlformats.org/officeDocument/2006/relationships" xmlns:mc="http://schemas.openxmlformats.org/markup-compatibility/2006" xmlns:mv="urn:schemas-microsoft-com:mac:vml" xmlns:p="http://schemas.openxmlformats.org/presentationml/2006/main" xmlns:c="http://schemas.openxmlformats.org/drawingml/2006/chart" xmlns:dgm="http://schemas.openxmlformats.org/drawingml/2006/diagram" xmlns:o="urn:schemas-microsoft-com:office:office" xmlns:v="urn:schemas-microsoft-com:vml" xmlns:pvml="urn:schemas-microsoft-com:office:powerpoint" xmlns:com="http://schemas.openxmlformats.org/drawingml/2006/compatibility" xmlns:p14="http://schemas.microsoft.com/office/powerpoint/2010/main" xmlns:p15="http://schemas.microsoft.com/office/powerpoint/2012/main" xmlns:ahyp="http://schemas.microsoft.com/office/drawing/2018/hyperlinkcolor" matchingName="Title only" type="titleOnly">
+<p:sldLayout xmlns:a="http://schemas.openxmlformats.org/drawingml/2006/main" xmlns:r="http://schemas.openxmlformats.org/officeDocument/2006/relationships" xmlns:p="http://schemas.openxmlformats.org/presentationml/2006/main" matchingName="Title only" type="titleOnly">
   <p:cSld name="TITLE_ONLY">
     <p:spTree>
       <p:nvGrpSpPr>
-        <p:cNvPr id="25" name="Shape 25"/>
+        <p:cNvPr id="1" name="Shape 25"/>
         <p:cNvGrpSpPr/>
         <p:nvPr/>
       </p:nvGrpSpPr>
@@ -2698,7 +2805,9 @@
       <p:sp>
         <p:nvSpPr>
           <p:cNvPr id="26" name="Google Shape;26;p6"/>
-          <p:cNvSpPr txBox="1"/>
+          <p:cNvSpPr txBox="1">
+            <a:spLocks noGrp="1"/>
+          </p:cNvSpPr>
           <p:nvPr>
             <p:ph type="title"/>
           </p:nvPr>
@@ -2713,7 +2822,7 @@
           </a:prstGeom>
         </p:spPr>
         <p:txBody>
-          <a:bodyPr anchorCtr="0" anchor="t" bIns="91425" lIns="91425" spcFirstLastPara="1" rIns="91425" wrap="square" tIns="91425">
+          <a:bodyPr spcFirstLastPara="1" wrap="square" lIns="91425" tIns="91425" rIns="91425" bIns="91425" anchor="t" anchorCtr="0">
             <a:normAutofit/>
           </a:bodyPr>
           <a:lstStyle>
@@ -2817,15 +2926,19 @@
               <a:defRPr/>
             </a:lvl9pPr>
           </a:lstStyle>
-          <a:p/>
+          <a:p>
+            <a:endParaRPr/>
+          </a:p>
         </p:txBody>
       </p:sp>
       <p:sp>
         <p:nvSpPr>
           <p:cNvPr id="27" name="Google Shape;27;p6"/>
-          <p:cNvSpPr txBox="1"/>
+          <p:cNvSpPr txBox="1">
+            <a:spLocks noGrp="1"/>
+          </p:cNvSpPr>
           <p:nvPr>
-            <p:ph idx="12" type="sldNum"/>
+            <p:ph type="sldNum" idx="12"/>
           </p:nvPr>
         </p:nvSpPr>
         <p:spPr>
@@ -2838,7 +2951,7 @@
           </a:prstGeom>
         </p:spPr>
         <p:txBody>
-          <a:bodyPr anchorCtr="0" anchor="ctr" bIns="91425" lIns="91425" spcFirstLastPara="1" rIns="91425" wrap="square" tIns="91425">
+          <a:bodyPr spcFirstLastPara="1" wrap="square" lIns="91425" tIns="91425" rIns="91425" bIns="91425" anchor="ctr" anchorCtr="0">
             <a:normAutofit/>
           </a:bodyPr>
           <a:lstStyle>
@@ -2880,7 +2993,7 @@
             </a:lvl9pPr>
           </a:lstStyle>
           <a:p>
-            <a:pPr indent="0" lvl="0" marL="0" rtl="0" algn="r">
+            <a:pPr marL="0" lvl="0" indent="0" algn="r" rtl="0">
               <a:spcBef>
                 <a:spcPts val="0"/>
               </a:spcBef>
@@ -2906,11 +3019,11 @@
 </file>
 
 <file path=ppt/slideLayouts/slideLayout6.xml><?xml version="1.0" encoding="utf-8"?>
-<p:sldLayout xmlns:a="http://schemas.openxmlformats.org/drawingml/2006/main" xmlns:r="http://schemas.openxmlformats.org/officeDocument/2006/relationships" xmlns:mc="http://schemas.openxmlformats.org/markup-compatibility/2006" xmlns:mv="urn:schemas-microsoft-com:mac:vml" xmlns:p="http://schemas.openxmlformats.org/presentationml/2006/main" xmlns:c="http://schemas.openxmlformats.org/drawingml/2006/chart" xmlns:dgm="http://schemas.openxmlformats.org/drawingml/2006/diagram" xmlns:o="urn:schemas-microsoft-com:office:office" xmlns:v="urn:schemas-microsoft-com:vml" xmlns:pvml="urn:schemas-microsoft-com:office:powerpoint" xmlns:com="http://schemas.openxmlformats.org/drawingml/2006/compatibility" xmlns:p14="http://schemas.microsoft.com/office/powerpoint/2010/main" xmlns:p15="http://schemas.microsoft.com/office/powerpoint/2012/main" xmlns:ahyp="http://schemas.microsoft.com/office/drawing/2018/hyperlinkcolor" matchingName="One column text">
+<p:sldLayout xmlns:a="http://schemas.openxmlformats.org/drawingml/2006/main" xmlns:r="http://schemas.openxmlformats.org/officeDocument/2006/relationships" xmlns:p="http://schemas.openxmlformats.org/presentationml/2006/main" matchingName="One column text">
   <p:cSld name="ONE_COLUMN_TEXT">
     <p:spTree>
       <p:nvGrpSpPr>
-        <p:cNvPr id="28" name="Shape 28"/>
+        <p:cNvPr id="1" name="Shape 28"/>
         <p:cNvGrpSpPr/>
         <p:nvPr/>
       </p:nvGrpSpPr>
@@ -2925,7 +3038,9 @@
       <p:sp>
         <p:nvSpPr>
           <p:cNvPr id="29" name="Google Shape;29;p7"/>
-          <p:cNvSpPr txBox="1"/>
+          <p:cNvSpPr txBox="1">
+            <a:spLocks noGrp="1"/>
+          </p:cNvSpPr>
           <p:nvPr>
             <p:ph type="title"/>
           </p:nvPr>
@@ -2940,7 +3055,7 @@
           </a:prstGeom>
         </p:spPr>
         <p:txBody>
-          <a:bodyPr anchorCtr="0" anchor="b" bIns="91425" lIns="91425" spcFirstLastPara="1" rIns="91425" wrap="square" tIns="91425">
+          <a:bodyPr spcFirstLastPara="1" wrap="square" lIns="91425" tIns="91425" rIns="91425" bIns="91425" anchor="b" anchorCtr="0">
             <a:normAutofit/>
           </a:bodyPr>
           <a:lstStyle>
@@ -3044,15 +3159,19 @@
               <a:defRPr sz="2400"/>
             </a:lvl9pPr>
           </a:lstStyle>
-          <a:p/>
+          <a:p>
+            <a:endParaRPr/>
+          </a:p>
         </p:txBody>
       </p:sp>
       <p:sp>
         <p:nvSpPr>
           <p:cNvPr id="30" name="Google Shape;30;p7"/>
-          <p:cNvSpPr txBox="1"/>
+          <p:cNvSpPr txBox="1">
+            <a:spLocks noGrp="1"/>
+          </p:cNvSpPr>
           <p:nvPr>
-            <p:ph idx="1" type="body"/>
+            <p:ph type="body" idx="1"/>
           </p:nvPr>
         </p:nvSpPr>
         <p:spPr>
@@ -3065,11 +3184,11 @@
           </a:prstGeom>
         </p:spPr>
         <p:txBody>
-          <a:bodyPr anchorCtr="0" anchor="t" bIns="91425" lIns="91425" spcFirstLastPara="1" rIns="91425" wrap="square" tIns="91425">
+          <a:bodyPr spcFirstLastPara="1" wrap="square" lIns="91425" tIns="91425" rIns="91425" bIns="91425" anchor="t" anchorCtr="0">
             <a:normAutofit/>
           </a:bodyPr>
           <a:lstStyle>
-            <a:lvl1pPr indent="-304800" lvl="0" marL="457200">
+            <a:lvl1pPr marL="457200" lvl="0" indent="-304800">
               <a:spcBef>
                 <a:spcPts val="0"/>
               </a:spcBef>
@@ -3080,7 +3199,7 @@
               <a:buChar char="●"/>
               <a:defRPr sz="1200"/>
             </a:lvl1pPr>
-            <a:lvl2pPr indent="-304800" lvl="1" marL="914400">
+            <a:lvl2pPr marL="914400" lvl="1" indent="-304800">
               <a:spcBef>
                 <a:spcPts val="0"/>
               </a:spcBef>
@@ -3091,7 +3210,7 @@
               <a:buChar char="○"/>
               <a:defRPr sz="1200"/>
             </a:lvl2pPr>
-            <a:lvl3pPr indent="-304800" lvl="2" marL="1371600">
+            <a:lvl3pPr marL="1371600" lvl="2" indent="-304800">
               <a:spcBef>
                 <a:spcPts val="0"/>
               </a:spcBef>
@@ -3102,7 +3221,7 @@
               <a:buChar char="■"/>
               <a:defRPr sz="1200"/>
             </a:lvl3pPr>
-            <a:lvl4pPr indent="-304800" lvl="3" marL="1828800">
+            <a:lvl4pPr marL="1828800" lvl="3" indent="-304800">
               <a:spcBef>
                 <a:spcPts val="0"/>
               </a:spcBef>
@@ -3113,7 +3232,7 @@
               <a:buChar char="●"/>
               <a:defRPr sz="1200"/>
             </a:lvl4pPr>
-            <a:lvl5pPr indent="-304800" lvl="4" marL="2286000">
+            <a:lvl5pPr marL="2286000" lvl="4" indent="-304800">
               <a:spcBef>
                 <a:spcPts val="0"/>
               </a:spcBef>
@@ -3124,7 +3243,7 @@
               <a:buChar char="○"/>
               <a:defRPr sz="1200"/>
             </a:lvl5pPr>
-            <a:lvl6pPr indent="-304800" lvl="5" marL="2743200">
+            <a:lvl6pPr marL="2743200" lvl="5" indent="-304800">
               <a:spcBef>
                 <a:spcPts val="0"/>
               </a:spcBef>
@@ -3135,7 +3254,7 @@
               <a:buChar char="■"/>
               <a:defRPr sz="1200"/>
             </a:lvl6pPr>
-            <a:lvl7pPr indent="-304800" lvl="6" marL="3200400">
+            <a:lvl7pPr marL="3200400" lvl="6" indent="-304800">
               <a:spcBef>
                 <a:spcPts val="0"/>
               </a:spcBef>
@@ -3146,7 +3265,7 @@
               <a:buChar char="●"/>
               <a:defRPr sz="1200"/>
             </a:lvl7pPr>
-            <a:lvl8pPr indent="-304800" lvl="7" marL="3657600">
+            <a:lvl8pPr marL="3657600" lvl="7" indent="-304800">
               <a:spcBef>
                 <a:spcPts val="0"/>
               </a:spcBef>
@@ -3157,7 +3276,7 @@
               <a:buChar char="○"/>
               <a:defRPr sz="1200"/>
             </a:lvl8pPr>
-            <a:lvl9pPr indent="-304800" lvl="8" marL="4114800">
+            <a:lvl9pPr marL="4114800" lvl="8" indent="-304800">
               <a:spcBef>
                 <a:spcPts val="0"/>
               </a:spcBef>
@@ -3169,15 +3288,19 @@
               <a:defRPr sz="1200"/>
             </a:lvl9pPr>
           </a:lstStyle>
-          <a:p/>
+          <a:p>
+            <a:endParaRPr/>
+          </a:p>
         </p:txBody>
       </p:sp>
       <p:sp>
         <p:nvSpPr>
           <p:cNvPr id="31" name="Google Shape;31;p7"/>
-          <p:cNvSpPr txBox="1"/>
+          <p:cNvSpPr txBox="1">
+            <a:spLocks noGrp="1"/>
+          </p:cNvSpPr>
           <p:nvPr>
-            <p:ph idx="12" type="sldNum"/>
+            <p:ph type="sldNum" idx="12"/>
           </p:nvPr>
         </p:nvSpPr>
         <p:spPr>
@@ -3190,7 +3313,7 @@
           </a:prstGeom>
         </p:spPr>
         <p:txBody>
-          <a:bodyPr anchorCtr="0" anchor="ctr" bIns="91425" lIns="91425" spcFirstLastPara="1" rIns="91425" wrap="square" tIns="91425">
+          <a:bodyPr spcFirstLastPara="1" wrap="square" lIns="91425" tIns="91425" rIns="91425" bIns="91425" anchor="ctr" anchorCtr="0">
             <a:normAutofit/>
           </a:bodyPr>
           <a:lstStyle>
@@ -3232,7 +3355,7 @@
             </a:lvl9pPr>
           </a:lstStyle>
           <a:p>
-            <a:pPr indent="0" lvl="0" marL="0" rtl="0" algn="r">
+            <a:pPr marL="0" lvl="0" indent="0" algn="r" rtl="0">
               <a:spcBef>
                 <a:spcPts val="0"/>
               </a:spcBef>
@@ -3258,11 +3381,11 @@
 </file>
 
 <file path=ppt/slideLayouts/slideLayout7.xml><?xml version="1.0" encoding="utf-8"?>
-<p:sldLayout xmlns:a="http://schemas.openxmlformats.org/drawingml/2006/main" xmlns:r="http://schemas.openxmlformats.org/officeDocument/2006/relationships" xmlns:mc="http://schemas.openxmlformats.org/markup-compatibility/2006" xmlns:mv="urn:schemas-microsoft-com:mac:vml" xmlns:p="http://schemas.openxmlformats.org/presentationml/2006/main" xmlns:c="http://schemas.openxmlformats.org/drawingml/2006/chart" xmlns:dgm="http://schemas.openxmlformats.org/drawingml/2006/diagram" xmlns:o="urn:schemas-microsoft-com:office:office" xmlns:v="urn:schemas-microsoft-com:vml" xmlns:pvml="urn:schemas-microsoft-com:office:powerpoint" xmlns:com="http://schemas.openxmlformats.org/drawingml/2006/compatibility" xmlns:p14="http://schemas.microsoft.com/office/powerpoint/2010/main" xmlns:p15="http://schemas.microsoft.com/office/powerpoint/2012/main" xmlns:ahyp="http://schemas.microsoft.com/office/drawing/2018/hyperlinkcolor" matchingName="Main point">
+<p:sldLayout xmlns:a="http://schemas.openxmlformats.org/drawingml/2006/main" xmlns:r="http://schemas.openxmlformats.org/officeDocument/2006/relationships" xmlns:p="http://schemas.openxmlformats.org/presentationml/2006/main" matchingName="Main point">
   <p:cSld name="MAIN_POINT">
     <p:spTree>
       <p:nvGrpSpPr>
-        <p:cNvPr id="32" name="Shape 32"/>
+        <p:cNvPr id="1" name="Shape 32"/>
         <p:cNvGrpSpPr/>
         <p:nvPr/>
       </p:nvGrpSpPr>
@@ -3277,7 +3400,9 @@
       <p:sp>
         <p:nvSpPr>
           <p:cNvPr id="33" name="Google Shape;33;p8"/>
-          <p:cNvSpPr txBox="1"/>
+          <p:cNvSpPr txBox="1">
+            <a:spLocks noGrp="1"/>
+          </p:cNvSpPr>
           <p:nvPr>
             <p:ph type="title"/>
           </p:nvPr>
@@ -3292,7 +3417,7 @@
           </a:prstGeom>
         </p:spPr>
         <p:txBody>
-          <a:bodyPr anchorCtr="0" anchor="ctr" bIns="91425" lIns="91425" spcFirstLastPara="1" rIns="91425" wrap="square" tIns="91425">
+          <a:bodyPr spcFirstLastPara="1" wrap="square" lIns="91425" tIns="91425" rIns="91425" bIns="91425" anchor="ctr" anchorCtr="0">
             <a:normAutofit/>
           </a:bodyPr>
           <a:lstStyle>
@@ -3396,15 +3521,19 @@
               <a:defRPr sz="4800"/>
             </a:lvl9pPr>
           </a:lstStyle>
-          <a:p/>
+          <a:p>
+            <a:endParaRPr/>
+          </a:p>
         </p:txBody>
       </p:sp>
       <p:sp>
         <p:nvSpPr>
           <p:cNvPr id="34" name="Google Shape;34;p8"/>
-          <p:cNvSpPr txBox="1"/>
+          <p:cNvSpPr txBox="1">
+            <a:spLocks noGrp="1"/>
+          </p:cNvSpPr>
           <p:nvPr>
-            <p:ph idx="12" type="sldNum"/>
+            <p:ph type="sldNum" idx="12"/>
           </p:nvPr>
         </p:nvSpPr>
         <p:spPr>
@@ -3417,7 +3546,7 @@
           </a:prstGeom>
         </p:spPr>
         <p:txBody>
-          <a:bodyPr anchorCtr="0" anchor="ctr" bIns="91425" lIns="91425" spcFirstLastPara="1" rIns="91425" wrap="square" tIns="91425">
+          <a:bodyPr spcFirstLastPara="1" wrap="square" lIns="91425" tIns="91425" rIns="91425" bIns="91425" anchor="ctr" anchorCtr="0">
             <a:normAutofit/>
           </a:bodyPr>
           <a:lstStyle>
@@ -3459,7 +3588,7 @@
             </a:lvl9pPr>
           </a:lstStyle>
           <a:p>
-            <a:pPr indent="0" lvl="0" marL="0" rtl="0" algn="r">
+            <a:pPr marL="0" lvl="0" indent="0" algn="r" rtl="0">
               <a:spcBef>
                 <a:spcPts val="0"/>
               </a:spcBef>
@@ -3485,11 +3614,11 @@
 </file>
 
 <file path=ppt/slideLayouts/slideLayout8.xml><?xml version="1.0" encoding="utf-8"?>
-<p:sldLayout xmlns:a="http://schemas.openxmlformats.org/drawingml/2006/main" xmlns:r="http://schemas.openxmlformats.org/officeDocument/2006/relationships" xmlns:mc="http://schemas.openxmlformats.org/markup-compatibility/2006" xmlns:mv="urn:schemas-microsoft-com:mac:vml" xmlns:p="http://schemas.openxmlformats.org/presentationml/2006/main" xmlns:c="http://schemas.openxmlformats.org/drawingml/2006/chart" xmlns:dgm="http://schemas.openxmlformats.org/drawingml/2006/diagram" xmlns:o="urn:schemas-microsoft-com:office:office" xmlns:v="urn:schemas-microsoft-com:vml" xmlns:pvml="urn:schemas-microsoft-com:office:powerpoint" xmlns:com="http://schemas.openxmlformats.org/drawingml/2006/compatibility" xmlns:p14="http://schemas.microsoft.com/office/powerpoint/2010/main" xmlns:p15="http://schemas.microsoft.com/office/powerpoint/2012/main" xmlns:ahyp="http://schemas.microsoft.com/office/drawing/2018/hyperlinkcolor" matchingName="Section title and description">
+<p:sldLayout xmlns:a="http://schemas.openxmlformats.org/drawingml/2006/main" xmlns:r="http://schemas.openxmlformats.org/officeDocument/2006/relationships" xmlns:p="http://schemas.openxmlformats.org/presentationml/2006/main" matchingName="Section title and description">
   <p:cSld name="SECTION_TITLE_AND_DESCRIPTION">
     <p:spTree>
       <p:nvGrpSpPr>
-        <p:cNvPr id="35" name="Shape 35"/>
+        <p:cNvPr id="1" name="Shape 35"/>
         <p:cNvGrpSpPr/>
         <p:nvPr/>
       </p:nvGrpSpPr>
@@ -3523,12 +3652,12 @@
           </a:ln>
         </p:spPr>
         <p:txBody>
-          <a:bodyPr anchorCtr="0" anchor="ctr" bIns="91425" lIns="91425" spcFirstLastPara="1" rIns="91425" wrap="square" tIns="91425">
+          <a:bodyPr spcFirstLastPara="1" wrap="square" lIns="91425" tIns="91425" rIns="91425" bIns="91425" anchor="ctr" anchorCtr="0">
             <a:noAutofit/>
           </a:bodyPr>
           <a:lstStyle/>
           <a:p>
-            <a:pPr indent="0" lvl="0" marL="0" rtl="0" algn="l">
+            <a:pPr marL="0" lvl="0" indent="0" algn="l" rtl="0">
               <a:spcBef>
                 <a:spcPts val="0"/>
               </a:spcBef>
@@ -3537,9 +3666,6 @@
               </a:spcAft>
               <a:buNone/>
             </a:pPr>
-            <a:r>
-              <a:t/>
-            </a:r>
             <a:endParaRPr/>
           </a:p>
         </p:txBody>
@@ -3547,7 +3673,9 @@
       <p:sp>
         <p:nvSpPr>
           <p:cNvPr id="37" name="Google Shape;37;p9"/>
-          <p:cNvSpPr txBox="1"/>
+          <p:cNvSpPr txBox="1">
+            <a:spLocks noGrp="1"/>
+          </p:cNvSpPr>
           <p:nvPr>
             <p:ph type="title"/>
           </p:nvPr>
@@ -3562,7 +3690,7 @@
           </a:prstGeom>
         </p:spPr>
         <p:txBody>
-          <a:bodyPr anchorCtr="0" anchor="b" bIns="91425" lIns="91425" spcFirstLastPara="1" rIns="91425" wrap="square" tIns="91425">
+          <a:bodyPr spcFirstLastPara="1" wrap="square" lIns="91425" tIns="91425" rIns="91425" bIns="91425" anchor="b" anchorCtr="0">
             <a:normAutofit/>
           </a:bodyPr>
           <a:lstStyle>
@@ -3666,15 +3794,19 @@
               <a:defRPr sz="4200"/>
             </a:lvl9pPr>
           </a:lstStyle>
-          <a:p/>
+          <a:p>
+            <a:endParaRPr/>
+          </a:p>
         </p:txBody>
       </p:sp>
       <p:sp>
         <p:nvSpPr>
           <p:cNvPr id="38" name="Google Shape;38;p9"/>
-          <p:cNvSpPr txBox="1"/>
+          <p:cNvSpPr txBox="1">
+            <a:spLocks noGrp="1"/>
+          </p:cNvSpPr>
           <p:nvPr>
-            <p:ph idx="1" type="subTitle"/>
+            <p:ph type="subTitle" idx="1"/>
           </p:nvPr>
         </p:nvSpPr>
         <p:spPr>
@@ -3687,7 +3819,7 @@
           </a:prstGeom>
         </p:spPr>
         <p:txBody>
-          <a:bodyPr anchorCtr="0" anchor="t" bIns="91425" lIns="91425" spcFirstLastPara="1" rIns="91425" wrap="square" tIns="91425">
+          <a:bodyPr spcFirstLastPara="1" wrap="square" lIns="91425" tIns="91425" rIns="91425" bIns="91425" anchor="t" anchorCtr="0">
             <a:normAutofit/>
           </a:bodyPr>
           <a:lstStyle>
@@ -3818,15 +3950,19 @@
               <a:defRPr sz="2100"/>
             </a:lvl9pPr>
           </a:lstStyle>
-          <a:p/>
+          <a:p>
+            <a:endParaRPr/>
+          </a:p>
         </p:txBody>
       </p:sp>
       <p:sp>
         <p:nvSpPr>
           <p:cNvPr id="39" name="Google Shape;39;p9"/>
-          <p:cNvSpPr txBox="1"/>
+          <p:cNvSpPr txBox="1">
+            <a:spLocks noGrp="1"/>
+          </p:cNvSpPr>
           <p:nvPr>
-            <p:ph idx="2" type="body"/>
+            <p:ph type="body" idx="2"/>
           </p:nvPr>
         </p:nvSpPr>
         <p:spPr>
@@ -3839,11 +3975,11 @@
           </a:prstGeom>
         </p:spPr>
         <p:txBody>
-          <a:bodyPr anchorCtr="0" anchor="ctr" bIns="91425" lIns="91425" spcFirstLastPara="1" rIns="91425" wrap="square" tIns="91425">
+          <a:bodyPr spcFirstLastPara="1" wrap="square" lIns="91425" tIns="91425" rIns="91425" bIns="91425" anchor="ctr" anchorCtr="0">
             <a:normAutofit/>
           </a:bodyPr>
           <a:lstStyle>
-            <a:lvl1pPr indent="-342900" lvl="0" marL="457200">
+            <a:lvl1pPr marL="457200" lvl="0" indent="-342900">
               <a:spcBef>
                 <a:spcPts val="0"/>
               </a:spcBef>
@@ -3854,7 +3990,7 @@
               <a:buChar char="●"/>
               <a:defRPr/>
             </a:lvl1pPr>
-            <a:lvl2pPr indent="-317500" lvl="1" marL="914400">
+            <a:lvl2pPr marL="914400" lvl="1" indent="-317500">
               <a:spcBef>
                 <a:spcPts val="0"/>
               </a:spcBef>
@@ -3865,7 +4001,7 @@
               <a:buChar char="○"/>
               <a:defRPr/>
             </a:lvl2pPr>
-            <a:lvl3pPr indent="-317500" lvl="2" marL="1371600">
+            <a:lvl3pPr marL="1371600" lvl="2" indent="-317500">
               <a:spcBef>
                 <a:spcPts val="0"/>
               </a:spcBef>
@@ -3876,7 +4012,7 @@
               <a:buChar char="■"/>
               <a:defRPr/>
             </a:lvl3pPr>
-            <a:lvl4pPr indent="-317500" lvl="3" marL="1828800">
+            <a:lvl4pPr marL="1828800" lvl="3" indent="-317500">
               <a:spcBef>
                 <a:spcPts val="0"/>
               </a:spcBef>
@@ -3887,7 +4023,7 @@
               <a:buChar char="●"/>
               <a:defRPr/>
             </a:lvl4pPr>
-            <a:lvl5pPr indent="-317500" lvl="4" marL="2286000">
+            <a:lvl5pPr marL="2286000" lvl="4" indent="-317500">
               <a:spcBef>
                 <a:spcPts val="0"/>
               </a:spcBef>
@@ -3898,7 +4034,7 @@
               <a:buChar char="○"/>
               <a:defRPr/>
             </a:lvl5pPr>
-            <a:lvl6pPr indent="-317500" lvl="5" marL="2743200">
+            <a:lvl6pPr marL="2743200" lvl="5" indent="-317500">
               <a:spcBef>
                 <a:spcPts val="0"/>
               </a:spcBef>
@@ -3909,7 +4045,7 @@
               <a:buChar char="■"/>
               <a:defRPr/>
             </a:lvl6pPr>
-            <a:lvl7pPr indent="-317500" lvl="6" marL="3200400">
+            <a:lvl7pPr marL="3200400" lvl="6" indent="-317500">
               <a:spcBef>
                 <a:spcPts val="0"/>
               </a:spcBef>
@@ -3920,7 +4056,7 @@
               <a:buChar char="●"/>
               <a:defRPr/>
             </a:lvl7pPr>
-            <a:lvl8pPr indent="-317500" lvl="7" marL="3657600">
+            <a:lvl8pPr marL="3657600" lvl="7" indent="-317500">
               <a:spcBef>
                 <a:spcPts val="0"/>
               </a:spcBef>
@@ -3931,7 +4067,7 @@
               <a:buChar char="○"/>
               <a:defRPr/>
             </a:lvl8pPr>
-            <a:lvl9pPr indent="-317500" lvl="8" marL="4114800">
+            <a:lvl9pPr marL="4114800" lvl="8" indent="-317500">
               <a:spcBef>
                 <a:spcPts val="0"/>
               </a:spcBef>
@@ -3943,15 +4079,19 @@
               <a:defRPr/>
             </a:lvl9pPr>
           </a:lstStyle>
-          <a:p/>
+          <a:p>
+            <a:endParaRPr/>
+          </a:p>
         </p:txBody>
       </p:sp>
       <p:sp>
         <p:nvSpPr>
           <p:cNvPr id="40" name="Google Shape;40;p9"/>
-          <p:cNvSpPr txBox="1"/>
+          <p:cNvSpPr txBox="1">
+            <a:spLocks noGrp="1"/>
+          </p:cNvSpPr>
           <p:nvPr>
-            <p:ph idx="12" type="sldNum"/>
+            <p:ph type="sldNum" idx="12"/>
           </p:nvPr>
         </p:nvSpPr>
         <p:spPr>
@@ -3964,7 +4104,7 @@
           </a:prstGeom>
         </p:spPr>
         <p:txBody>
-          <a:bodyPr anchorCtr="0" anchor="ctr" bIns="91425" lIns="91425" spcFirstLastPara="1" rIns="91425" wrap="square" tIns="91425">
+          <a:bodyPr spcFirstLastPara="1" wrap="square" lIns="91425" tIns="91425" rIns="91425" bIns="91425" anchor="ctr" anchorCtr="0">
             <a:normAutofit/>
           </a:bodyPr>
           <a:lstStyle>
@@ -4006,7 +4146,7 @@
             </a:lvl9pPr>
           </a:lstStyle>
           <a:p>
-            <a:pPr indent="0" lvl="0" marL="0" rtl="0" algn="r">
+            <a:pPr marL="0" lvl="0" indent="0" algn="r" rtl="0">
               <a:spcBef>
                 <a:spcPts val="0"/>
               </a:spcBef>
@@ -4032,11 +4172,11 @@
 </file>
 
 <file path=ppt/slideLayouts/slideLayout9.xml><?xml version="1.0" encoding="utf-8"?>
-<p:sldLayout xmlns:a="http://schemas.openxmlformats.org/drawingml/2006/main" xmlns:r="http://schemas.openxmlformats.org/officeDocument/2006/relationships" xmlns:mc="http://schemas.openxmlformats.org/markup-compatibility/2006" xmlns:mv="urn:schemas-microsoft-com:mac:vml" xmlns:p="http://schemas.openxmlformats.org/presentationml/2006/main" xmlns:c="http://schemas.openxmlformats.org/drawingml/2006/chart" xmlns:dgm="http://schemas.openxmlformats.org/drawingml/2006/diagram" xmlns:o="urn:schemas-microsoft-com:office:office" xmlns:v="urn:schemas-microsoft-com:vml" xmlns:pvml="urn:schemas-microsoft-com:office:powerpoint" xmlns:com="http://schemas.openxmlformats.org/drawingml/2006/compatibility" xmlns:p14="http://schemas.microsoft.com/office/powerpoint/2010/main" xmlns:p15="http://schemas.microsoft.com/office/powerpoint/2012/main" xmlns:ahyp="http://schemas.microsoft.com/office/drawing/2018/hyperlinkcolor" matchingName="Caption">
+<p:sldLayout xmlns:a="http://schemas.openxmlformats.org/drawingml/2006/main" xmlns:r="http://schemas.openxmlformats.org/officeDocument/2006/relationships" xmlns:p="http://schemas.openxmlformats.org/presentationml/2006/main" matchingName="Caption">
   <p:cSld name="CAPTION_ONLY">
     <p:spTree>
       <p:nvGrpSpPr>
-        <p:cNvPr id="41" name="Shape 41"/>
+        <p:cNvPr id="1" name="Shape 41"/>
         <p:cNvGrpSpPr/>
         <p:nvPr/>
       </p:nvGrpSpPr>
@@ -4051,9 +4191,11 @@
       <p:sp>
         <p:nvSpPr>
           <p:cNvPr id="42" name="Google Shape;42;p10"/>
-          <p:cNvSpPr txBox="1"/>
+          <p:cNvSpPr txBox="1">
+            <a:spLocks noGrp="1"/>
+          </p:cNvSpPr>
           <p:nvPr>
-            <p:ph idx="1" type="body"/>
+            <p:ph type="body" idx="1"/>
           </p:nvPr>
         </p:nvSpPr>
         <p:spPr>
@@ -4066,11 +4208,11 @@
           </a:prstGeom>
         </p:spPr>
         <p:txBody>
-          <a:bodyPr anchorCtr="0" anchor="ctr" bIns="91425" lIns="91425" spcFirstLastPara="1" rIns="91425" wrap="square" tIns="91425">
+          <a:bodyPr spcFirstLastPara="1" wrap="square" lIns="91425" tIns="91425" rIns="91425" bIns="91425" anchor="ctr" anchorCtr="0">
             <a:normAutofit/>
           </a:bodyPr>
           <a:lstStyle>
-            <a:lvl1pPr indent="-228600" lvl="0" marL="457200">
+            <a:lvl1pPr marL="457200" lvl="0" indent="-228600">
               <a:lnSpc>
                 <a:spcPct val="100000"/>
               </a:lnSpc>
@@ -4085,15 +4227,19 @@
               <a:defRPr/>
             </a:lvl1pPr>
           </a:lstStyle>
-          <a:p/>
+          <a:p>
+            <a:endParaRPr/>
+          </a:p>
         </p:txBody>
       </p:sp>
       <p:sp>
         <p:nvSpPr>
           <p:cNvPr id="43" name="Google Shape;43;p10"/>
-          <p:cNvSpPr txBox="1"/>
+          <p:cNvSpPr txBox="1">
+            <a:spLocks noGrp="1"/>
+          </p:cNvSpPr>
           <p:nvPr>
-            <p:ph idx="12" type="sldNum"/>
+            <p:ph type="sldNum" idx="12"/>
           </p:nvPr>
         </p:nvSpPr>
         <p:spPr>
@@ -4106,7 +4252,7 @@
           </a:prstGeom>
         </p:spPr>
         <p:txBody>
-          <a:bodyPr anchorCtr="0" anchor="ctr" bIns="91425" lIns="91425" spcFirstLastPara="1" rIns="91425" wrap="square" tIns="91425">
+          <a:bodyPr spcFirstLastPara="1" wrap="square" lIns="91425" tIns="91425" rIns="91425" bIns="91425" anchor="ctr" anchorCtr="0">
             <a:normAutofit/>
           </a:bodyPr>
           <a:lstStyle>
@@ -4148,7 +4294,7 @@
             </a:lvl9pPr>
           </a:lstStyle>
           <a:p>
-            <a:pPr indent="0" lvl="0" marL="0" rtl="0" algn="r">
+            <a:pPr marL="0" lvl="0" indent="0" algn="r" rtl="0">
               <a:spcBef>
                 <a:spcPts val="0"/>
               </a:spcBef>
@@ -4174,18 +4320,19 @@
 </file>
 
 <file path=ppt/slideMasters/slideMaster1.xml><?xml version="1.0" encoding="utf-8"?>
-<p:sldMaster xmlns:a="http://schemas.openxmlformats.org/drawingml/2006/main" xmlns:r="http://schemas.openxmlformats.org/officeDocument/2006/relationships" xmlns:mc="http://schemas.openxmlformats.org/markup-compatibility/2006" xmlns:mv="urn:schemas-microsoft-com:mac:vml" xmlns:p="http://schemas.openxmlformats.org/presentationml/2006/main" xmlns:c="http://schemas.openxmlformats.org/drawingml/2006/chart" xmlns:dgm="http://schemas.openxmlformats.org/drawingml/2006/diagram" xmlns:o="urn:schemas-microsoft-com:office:office" xmlns:v="urn:schemas-microsoft-com:vml" xmlns:pvml="urn:schemas-microsoft-com:office:powerpoint" xmlns:com="http://schemas.openxmlformats.org/drawingml/2006/compatibility" xmlns:p14="http://schemas.microsoft.com/office/powerpoint/2010/main" xmlns:p15="http://schemas.microsoft.com/office/powerpoint/2012/main" xmlns:ahyp="http://schemas.microsoft.com/office/drawing/2018/hyperlinkcolor">
+<p:sldMaster xmlns:a="http://schemas.openxmlformats.org/drawingml/2006/main" xmlns:r="http://schemas.openxmlformats.org/officeDocument/2006/relationships" xmlns:p="http://schemas.openxmlformats.org/presentationml/2006/main">
   <p:cSld name="simple-light-2">
     <p:bg>
       <p:bgPr>
         <a:solidFill>
           <a:schemeClr val="lt1"/>
         </a:solidFill>
+        <a:effectLst/>
       </p:bgPr>
     </p:bg>
     <p:spTree>
       <p:nvGrpSpPr>
-        <p:cNvPr id="5" name="Shape 5"/>
+        <p:cNvPr id="1" name="Shape 5"/>
         <p:cNvGrpSpPr/>
         <p:nvPr/>
       </p:nvGrpSpPr>
@@ -4200,7 +4347,9 @@
       <p:sp>
         <p:nvSpPr>
           <p:cNvPr id="6" name="Google Shape;6;p1"/>
-          <p:cNvSpPr txBox="1"/>
+          <p:cNvSpPr txBox="1">
+            <a:spLocks noGrp="1"/>
+          </p:cNvSpPr>
           <p:nvPr>
             <p:ph type="title"/>
           </p:nvPr>
@@ -4219,7 +4368,7 @@
           </a:ln>
         </p:spPr>
         <p:txBody>
-          <a:bodyPr anchorCtr="0" anchor="t" bIns="91425" lIns="91425" spcFirstLastPara="1" rIns="91425" wrap="square" tIns="91425">
+          <a:bodyPr spcFirstLastPara="1" wrap="square" lIns="91425" tIns="91425" rIns="91425" bIns="91425" anchor="t" anchorCtr="0">
             <a:normAutofit/>
           </a:bodyPr>
           <a:lstStyle>
@@ -4386,15 +4535,19 @@
               </a:defRPr>
             </a:lvl9pPr>
           </a:lstStyle>
-          <a:p/>
+          <a:p>
+            <a:endParaRPr/>
+          </a:p>
         </p:txBody>
       </p:sp>
       <p:sp>
         <p:nvSpPr>
           <p:cNvPr id="7" name="Google Shape;7;p1"/>
-          <p:cNvSpPr txBox="1"/>
+          <p:cNvSpPr txBox="1">
+            <a:spLocks noGrp="1"/>
+          </p:cNvSpPr>
           <p:nvPr>
-            <p:ph idx="1" type="body"/>
+            <p:ph type="body" idx="1"/>
           </p:nvPr>
         </p:nvSpPr>
         <p:spPr>
@@ -4411,11 +4564,11 @@
           </a:ln>
         </p:spPr>
         <p:txBody>
-          <a:bodyPr anchorCtr="0" anchor="t" bIns="91425" lIns="91425" spcFirstLastPara="1" rIns="91425" wrap="square" tIns="91425">
+          <a:bodyPr spcFirstLastPara="1" wrap="square" lIns="91425" tIns="91425" rIns="91425" bIns="91425" anchor="t" anchorCtr="0">
             <a:normAutofit/>
           </a:bodyPr>
           <a:lstStyle>
-            <a:lvl1pPr indent="-342900" lvl="0" marL="457200">
+            <a:lvl1pPr marL="457200" lvl="0" indent="-342900">
               <a:lnSpc>
                 <a:spcPct val="115000"/>
               </a:lnSpc>
@@ -4436,7 +4589,7 @@
                 </a:solidFill>
               </a:defRPr>
             </a:lvl1pPr>
-            <a:lvl2pPr indent="-317500" lvl="1" marL="914400">
+            <a:lvl2pPr marL="914400" lvl="1" indent="-317500">
               <a:lnSpc>
                 <a:spcPct val="115000"/>
               </a:lnSpc>
@@ -4457,7 +4610,7 @@
                 </a:solidFill>
               </a:defRPr>
             </a:lvl2pPr>
-            <a:lvl3pPr indent="-317500" lvl="2" marL="1371600">
+            <a:lvl3pPr marL="1371600" lvl="2" indent="-317500">
               <a:lnSpc>
                 <a:spcPct val="115000"/>
               </a:lnSpc>
@@ -4478,7 +4631,7 @@
                 </a:solidFill>
               </a:defRPr>
             </a:lvl3pPr>
-            <a:lvl4pPr indent="-317500" lvl="3" marL="1828800">
+            <a:lvl4pPr marL="1828800" lvl="3" indent="-317500">
               <a:lnSpc>
                 <a:spcPct val="115000"/>
               </a:lnSpc>
@@ -4499,7 +4652,7 @@
                 </a:solidFill>
               </a:defRPr>
             </a:lvl4pPr>
-            <a:lvl5pPr indent="-317500" lvl="4" marL="2286000">
+            <a:lvl5pPr marL="2286000" lvl="4" indent="-317500">
               <a:lnSpc>
                 <a:spcPct val="115000"/>
               </a:lnSpc>
@@ -4520,7 +4673,7 @@
                 </a:solidFill>
               </a:defRPr>
             </a:lvl5pPr>
-            <a:lvl6pPr indent="-317500" lvl="5" marL="2743200">
+            <a:lvl6pPr marL="2743200" lvl="5" indent="-317500">
               <a:lnSpc>
                 <a:spcPct val="115000"/>
               </a:lnSpc>
@@ -4541,7 +4694,7 @@
                 </a:solidFill>
               </a:defRPr>
             </a:lvl6pPr>
-            <a:lvl7pPr indent="-317500" lvl="6" marL="3200400">
+            <a:lvl7pPr marL="3200400" lvl="6" indent="-317500">
               <a:lnSpc>
                 <a:spcPct val="115000"/>
               </a:lnSpc>
@@ -4562,7 +4715,7 @@
                 </a:solidFill>
               </a:defRPr>
             </a:lvl7pPr>
-            <a:lvl8pPr indent="-317500" lvl="7" marL="3657600">
+            <a:lvl8pPr marL="3657600" lvl="7" indent="-317500">
               <a:lnSpc>
                 <a:spcPct val="115000"/>
               </a:lnSpc>
@@ -4583,7 +4736,7 @@
                 </a:solidFill>
               </a:defRPr>
             </a:lvl8pPr>
-            <a:lvl9pPr indent="-317500" lvl="8" marL="4114800">
+            <a:lvl9pPr marL="4114800" lvl="8" indent="-317500">
               <a:lnSpc>
                 <a:spcPct val="115000"/>
               </a:lnSpc>
@@ -4605,15 +4758,19 @@
               </a:defRPr>
             </a:lvl9pPr>
           </a:lstStyle>
-          <a:p/>
+          <a:p>
+            <a:endParaRPr/>
+          </a:p>
         </p:txBody>
       </p:sp>
       <p:sp>
         <p:nvSpPr>
           <p:cNvPr id="8" name="Google Shape;8;p1"/>
-          <p:cNvSpPr txBox="1"/>
+          <p:cNvSpPr txBox="1">
+            <a:spLocks noGrp="1"/>
+          </p:cNvSpPr>
           <p:nvPr>
-            <p:ph idx="12" type="sldNum"/>
+            <p:ph type="sldNum" idx="12"/>
           </p:nvPr>
         </p:nvSpPr>
         <p:spPr>
@@ -4630,7 +4787,7 @@
           </a:ln>
         </p:spPr>
         <p:txBody>
-          <a:bodyPr anchorCtr="0" anchor="ctr" bIns="91425" lIns="91425" spcFirstLastPara="1" rIns="91425" wrap="square" tIns="91425">
+          <a:bodyPr spcFirstLastPara="1" wrap="square" lIns="91425" tIns="91425" rIns="91425" bIns="91425" anchor="ctr" anchorCtr="0">
             <a:normAutofit/>
           </a:bodyPr>
           <a:lstStyle>
@@ -4708,7 +4865,7 @@
             </a:lvl9pPr>
           </a:lstStyle>
           <a:p>
-            <a:pPr indent="0" lvl="0" marL="0" rtl="0" algn="r">
+            <a:pPr marL="0" lvl="0" indent="0" algn="r" rtl="0">
               <a:spcBef>
                 <a:spcPts val="0"/>
               </a:spcBef>
@@ -4727,7 +4884,7 @@
       </p:sp>
     </p:spTree>
   </p:cSld>
-  <p:clrMap accent1="accent1" accent2="accent2" accent3="accent3" accent4="accent4" accent5="accent5" accent6="accent6" bg1="lt1" bg2="dk2" tx1="dk1" tx2="lt2" folHlink="folHlink" hlink="hlink"/>
+  <p:clrMap bg1="lt1" tx1="dk1" bg2="dk2" tx2="lt2" accent1="accent1" accent2="accent2" accent3="accent3" accent4="accent4" accent5="accent5" accent6="accent6" hlink="hlink" folHlink="folHlink"/>
   <p:sldLayoutIdLst>
     <p:sldLayoutId id="2147483648" r:id="rId1"/>
     <p:sldLayoutId id="2147483649" r:id="rId2"/>
@@ -4741,10 +4898,10 @@
     <p:sldLayoutId id="2147483657" r:id="rId10"/>
     <p:sldLayoutId id="2147483658" r:id="rId11"/>
   </p:sldLayoutIdLst>
-  <p:hf dt="0" ftr="0" hdr="0" sldNum="0"/>
+  <p:hf sldNum="0" hdr="0" ftr="0" dt="0"/>
   <p:txStyles>
     <p:titleStyle>
-      <a:defPPr lvl="0" marR="0" rtl="0" algn="l">
+      <a:defPPr marR="0" lvl="0" algn="l" rtl="0">
         <a:lnSpc>
           <a:spcPct val="100000"/>
         </a:lnSpc>
@@ -4755,7 +4912,7 @@
           <a:spcPts val="0"/>
         </a:spcAft>
       </a:defPPr>
-      <a:lvl1pPr lvl="0" marR="0" rtl="0" algn="l">
+      <a:lvl1pPr marR="0" lvl="0" algn="l" rtl="0">
         <a:lnSpc>
           <a:spcPct val="100000"/>
         </a:lnSpc>
@@ -4769,7 +4926,7 @@
           <a:srgbClr val="000000"/>
         </a:buClr>
         <a:buFont typeface="Arial"/>
-        <a:defRPr b="0" i="0" sz="1400" u="none" cap="none" strike="noStrike">
+        <a:defRPr sz="1400" b="0" i="0" u="none" strike="noStrike" cap="none">
           <a:solidFill>
             <a:srgbClr val="000000"/>
           </a:solidFill>
@@ -4779,7 +4936,7 @@
           <a:sym typeface="Arial"/>
         </a:defRPr>
       </a:lvl1pPr>
-      <a:lvl2pPr lvl="1" marR="0" rtl="0" algn="l">
+      <a:lvl2pPr marR="0" lvl="1" algn="l" rtl="0">
         <a:lnSpc>
           <a:spcPct val="100000"/>
         </a:lnSpc>
@@ -4793,7 +4950,7 @@
           <a:srgbClr val="000000"/>
         </a:buClr>
         <a:buFont typeface="Arial"/>
-        <a:defRPr b="0" i="0" sz="1400" u="none" cap="none" strike="noStrike">
+        <a:defRPr sz="1400" b="0" i="0" u="none" strike="noStrike" cap="none">
           <a:solidFill>
             <a:srgbClr val="000000"/>
           </a:solidFill>
@@ -4803,7 +4960,7 @@
           <a:sym typeface="Arial"/>
         </a:defRPr>
       </a:lvl2pPr>
-      <a:lvl3pPr lvl="2" marR="0" rtl="0" algn="l">
+      <a:lvl3pPr marR="0" lvl="2" algn="l" rtl="0">
         <a:lnSpc>
           <a:spcPct val="100000"/>
         </a:lnSpc>
@@ -4817,7 +4974,7 @@
           <a:srgbClr val="000000"/>
         </a:buClr>
         <a:buFont typeface="Arial"/>
-        <a:defRPr b="0" i="0" sz="1400" u="none" cap="none" strike="noStrike">
+        <a:defRPr sz="1400" b="0" i="0" u="none" strike="noStrike" cap="none">
           <a:solidFill>
             <a:srgbClr val="000000"/>
           </a:solidFill>
@@ -4827,7 +4984,7 @@
           <a:sym typeface="Arial"/>
         </a:defRPr>
       </a:lvl3pPr>
-      <a:lvl4pPr lvl="3" marR="0" rtl="0" algn="l">
+      <a:lvl4pPr marR="0" lvl="3" algn="l" rtl="0">
         <a:lnSpc>
           <a:spcPct val="100000"/>
         </a:lnSpc>
@@ -4841,7 +4998,7 @@
           <a:srgbClr val="000000"/>
         </a:buClr>
         <a:buFont typeface="Arial"/>
-        <a:defRPr b="0" i="0" sz="1400" u="none" cap="none" strike="noStrike">
+        <a:defRPr sz="1400" b="0" i="0" u="none" strike="noStrike" cap="none">
           <a:solidFill>
             <a:srgbClr val="000000"/>
           </a:solidFill>
@@ -4851,7 +5008,7 @@
           <a:sym typeface="Arial"/>
         </a:defRPr>
       </a:lvl4pPr>
-      <a:lvl5pPr lvl="4" marR="0" rtl="0" algn="l">
+      <a:lvl5pPr marR="0" lvl="4" algn="l" rtl="0">
         <a:lnSpc>
           <a:spcPct val="100000"/>
         </a:lnSpc>
@@ -4865,7 +5022,7 @@
           <a:srgbClr val="000000"/>
         </a:buClr>
         <a:buFont typeface="Arial"/>
-        <a:defRPr b="0" i="0" sz="1400" u="none" cap="none" strike="noStrike">
+        <a:defRPr sz="1400" b="0" i="0" u="none" strike="noStrike" cap="none">
           <a:solidFill>
             <a:srgbClr val="000000"/>
           </a:solidFill>
@@ -4875,7 +5032,7 @@
           <a:sym typeface="Arial"/>
         </a:defRPr>
       </a:lvl5pPr>
-      <a:lvl6pPr lvl="5" marR="0" rtl="0" algn="l">
+      <a:lvl6pPr marR="0" lvl="5" algn="l" rtl="0">
         <a:lnSpc>
           <a:spcPct val="100000"/>
         </a:lnSpc>
@@ -4889,7 +5046,7 @@
           <a:srgbClr val="000000"/>
         </a:buClr>
         <a:buFont typeface="Arial"/>
-        <a:defRPr b="0" i="0" sz="1400" u="none" cap="none" strike="noStrike">
+        <a:defRPr sz="1400" b="0" i="0" u="none" strike="noStrike" cap="none">
           <a:solidFill>
             <a:srgbClr val="000000"/>
           </a:solidFill>
@@ -4899,7 +5056,7 @@
           <a:sym typeface="Arial"/>
         </a:defRPr>
       </a:lvl6pPr>
-      <a:lvl7pPr lvl="6" marR="0" rtl="0" algn="l">
+      <a:lvl7pPr marR="0" lvl="6" algn="l" rtl="0">
         <a:lnSpc>
           <a:spcPct val="100000"/>
         </a:lnSpc>
@@ -4913,7 +5070,7 @@
           <a:srgbClr val="000000"/>
         </a:buClr>
         <a:buFont typeface="Arial"/>
-        <a:defRPr b="0" i="0" sz="1400" u="none" cap="none" strike="noStrike">
+        <a:defRPr sz="1400" b="0" i="0" u="none" strike="noStrike" cap="none">
           <a:solidFill>
             <a:srgbClr val="000000"/>
           </a:solidFill>
@@ -4923,7 +5080,7 @@
           <a:sym typeface="Arial"/>
         </a:defRPr>
       </a:lvl7pPr>
-      <a:lvl8pPr lvl="7" marR="0" rtl="0" algn="l">
+      <a:lvl8pPr marR="0" lvl="7" algn="l" rtl="0">
         <a:lnSpc>
           <a:spcPct val="100000"/>
         </a:lnSpc>
@@ -4937,7 +5094,7 @@
           <a:srgbClr val="000000"/>
         </a:buClr>
         <a:buFont typeface="Arial"/>
-        <a:defRPr b="0" i="0" sz="1400" u="none" cap="none" strike="noStrike">
+        <a:defRPr sz="1400" b="0" i="0" u="none" strike="noStrike" cap="none">
           <a:solidFill>
             <a:srgbClr val="000000"/>
           </a:solidFill>
@@ -4947,7 +5104,7 @@
           <a:sym typeface="Arial"/>
         </a:defRPr>
       </a:lvl8pPr>
-      <a:lvl9pPr lvl="8" marR="0" rtl="0" algn="l">
+      <a:lvl9pPr marR="0" lvl="8" algn="l" rtl="0">
         <a:lnSpc>
           <a:spcPct val="100000"/>
         </a:lnSpc>
@@ -4961,7 +5118,7 @@
           <a:srgbClr val="000000"/>
         </a:buClr>
         <a:buFont typeface="Arial"/>
-        <a:defRPr b="0" i="0" sz="1400" u="none" cap="none" strike="noStrike">
+        <a:defRPr sz="1400" b="0" i="0" u="none" strike="noStrike" cap="none">
           <a:solidFill>
             <a:srgbClr val="000000"/>
           </a:solidFill>
@@ -4973,7 +5130,7 @@
       </a:lvl9pPr>
     </p:titleStyle>
     <p:bodyStyle>
-      <a:defPPr lvl="0" marR="0" rtl="0" algn="l">
+      <a:defPPr marR="0" lvl="0" algn="l" rtl="0">
         <a:lnSpc>
           <a:spcPct val="100000"/>
         </a:lnSpc>
@@ -4984,7 +5141,7 @@
           <a:spcPts val="0"/>
         </a:spcAft>
       </a:defPPr>
-      <a:lvl1pPr lvl="0" marR="0" rtl="0" algn="l">
+      <a:lvl1pPr marR="0" lvl="0" algn="l" rtl="0">
         <a:lnSpc>
           <a:spcPct val="100000"/>
         </a:lnSpc>
@@ -4998,7 +5155,7 @@
           <a:srgbClr val="000000"/>
         </a:buClr>
         <a:buFont typeface="Arial"/>
-        <a:defRPr b="0" i="0" sz="1400" u="none" cap="none" strike="noStrike">
+        <a:defRPr sz="1400" b="0" i="0" u="none" strike="noStrike" cap="none">
           <a:solidFill>
             <a:srgbClr val="000000"/>
           </a:solidFill>
@@ -5008,7 +5165,7 @@
           <a:sym typeface="Arial"/>
         </a:defRPr>
       </a:lvl1pPr>
-      <a:lvl2pPr lvl="1" marR="0" rtl="0" algn="l">
+      <a:lvl2pPr marR="0" lvl="1" algn="l" rtl="0">
         <a:lnSpc>
           <a:spcPct val="100000"/>
         </a:lnSpc>
@@ -5022,7 +5179,7 @@
           <a:srgbClr val="000000"/>
         </a:buClr>
         <a:buFont typeface="Arial"/>
-        <a:defRPr b="0" i="0" sz="1400" u="none" cap="none" strike="noStrike">
+        <a:defRPr sz="1400" b="0" i="0" u="none" strike="noStrike" cap="none">
           <a:solidFill>
             <a:srgbClr val="000000"/>
           </a:solidFill>
@@ -5032,7 +5189,7 @@
           <a:sym typeface="Arial"/>
         </a:defRPr>
       </a:lvl2pPr>
-      <a:lvl3pPr lvl="2" marR="0" rtl="0" algn="l">
+      <a:lvl3pPr marR="0" lvl="2" algn="l" rtl="0">
         <a:lnSpc>
           <a:spcPct val="100000"/>
         </a:lnSpc>
@@ -5046,7 +5203,7 @@
           <a:srgbClr val="000000"/>
         </a:buClr>
         <a:buFont typeface="Arial"/>
-        <a:defRPr b="0" i="0" sz="1400" u="none" cap="none" strike="noStrike">
+        <a:defRPr sz="1400" b="0" i="0" u="none" strike="noStrike" cap="none">
           <a:solidFill>
             <a:srgbClr val="000000"/>
           </a:solidFill>
@@ -5056,7 +5213,7 @@
           <a:sym typeface="Arial"/>
         </a:defRPr>
       </a:lvl3pPr>
-      <a:lvl4pPr lvl="3" marR="0" rtl="0" algn="l">
+      <a:lvl4pPr marR="0" lvl="3" algn="l" rtl="0">
         <a:lnSpc>
           <a:spcPct val="100000"/>
         </a:lnSpc>
@@ -5070,7 +5227,7 @@
           <a:srgbClr val="000000"/>
         </a:buClr>
         <a:buFont typeface="Arial"/>
-        <a:defRPr b="0" i="0" sz="1400" u="none" cap="none" strike="noStrike">
+        <a:defRPr sz="1400" b="0" i="0" u="none" strike="noStrike" cap="none">
           <a:solidFill>
             <a:srgbClr val="000000"/>
           </a:solidFill>
@@ -5080,7 +5237,7 @@
           <a:sym typeface="Arial"/>
         </a:defRPr>
       </a:lvl4pPr>
-      <a:lvl5pPr lvl="4" marR="0" rtl="0" algn="l">
+      <a:lvl5pPr marR="0" lvl="4" algn="l" rtl="0">
         <a:lnSpc>
           <a:spcPct val="100000"/>
         </a:lnSpc>
@@ -5094,7 +5251,7 @@
           <a:srgbClr val="000000"/>
         </a:buClr>
         <a:buFont typeface="Arial"/>
-        <a:defRPr b="0" i="0" sz="1400" u="none" cap="none" strike="noStrike">
+        <a:defRPr sz="1400" b="0" i="0" u="none" strike="noStrike" cap="none">
           <a:solidFill>
             <a:srgbClr val="000000"/>
           </a:solidFill>
@@ -5104,7 +5261,7 @@
           <a:sym typeface="Arial"/>
         </a:defRPr>
       </a:lvl5pPr>
-      <a:lvl6pPr lvl="5" marR="0" rtl="0" algn="l">
+      <a:lvl6pPr marR="0" lvl="5" algn="l" rtl="0">
         <a:lnSpc>
           <a:spcPct val="100000"/>
         </a:lnSpc>
@@ -5118,7 +5275,7 @@
           <a:srgbClr val="000000"/>
         </a:buClr>
         <a:buFont typeface="Arial"/>
-        <a:defRPr b="0" i="0" sz="1400" u="none" cap="none" strike="noStrike">
+        <a:defRPr sz="1400" b="0" i="0" u="none" strike="noStrike" cap="none">
           <a:solidFill>
             <a:srgbClr val="000000"/>
           </a:solidFill>
@@ -5128,7 +5285,7 @@
           <a:sym typeface="Arial"/>
         </a:defRPr>
       </a:lvl6pPr>
-      <a:lvl7pPr lvl="6" marR="0" rtl="0" algn="l">
+      <a:lvl7pPr marR="0" lvl="6" algn="l" rtl="0">
         <a:lnSpc>
           <a:spcPct val="100000"/>
         </a:lnSpc>
@@ -5142,7 +5299,7 @@
           <a:srgbClr val="000000"/>
         </a:buClr>
         <a:buFont typeface="Arial"/>
-        <a:defRPr b="0" i="0" sz="1400" u="none" cap="none" strike="noStrike">
+        <a:defRPr sz="1400" b="0" i="0" u="none" strike="noStrike" cap="none">
           <a:solidFill>
             <a:srgbClr val="000000"/>
           </a:solidFill>
@@ -5152,7 +5309,7 @@
           <a:sym typeface="Arial"/>
         </a:defRPr>
       </a:lvl7pPr>
-      <a:lvl8pPr lvl="7" marR="0" rtl="0" algn="l">
+      <a:lvl8pPr marR="0" lvl="7" algn="l" rtl="0">
         <a:lnSpc>
           <a:spcPct val="100000"/>
         </a:lnSpc>
@@ -5166,7 +5323,7 @@
           <a:srgbClr val="000000"/>
         </a:buClr>
         <a:buFont typeface="Arial"/>
-        <a:defRPr b="0" i="0" sz="1400" u="none" cap="none" strike="noStrike">
+        <a:defRPr sz="1400" b="0" i="0" u="none" strike="noStrike" cap="none">
           <a:solidFill>
             <a:srgbClr val="000000"/>
           </a:solidFill>
@@ -5176,7 +5333,7 @@
           <a:sym typeface="Arial"/>
         </a:defRPr>
       </a:lvl8pPr>
-      <a:lvl9pPr lvl="8" marR="0" rtl="0" algn="l">
+      <a:lvl9pPr marR="0" lvl="8" algn="l" rtl="0">
         <a:lnSpc>
           <a:spcPct val="100000"/>
         </a:lnSpc>
@@ -5190,7 +5347,7 @@
           <a:srgbClr val="000000"/>
         </a:buClr>
         <a:buFont typeface="Arial"/>
-        <a:defRPr b="0" i="0" sz="1400" u="none" cap="none" strike="noStrike">
+        <a:defRPr sz="1400" b="0" i="0" u="none" strike="noStrike" cap="none">
           <a:solidFill>
             <a:srgbClr val="000000"/>
           </a:solidFill>
@@ -5202,7 +5359,7 @@
       </a:lvl9pPr>
     </p:bodyStyle>
     <p:otherStyle>
-      <a:defPPr lvl="0" marR="0" rtl="0" algn="l">
+      <a:defPPr marR="0" lvl="0" algn="l" rtl="0">
         <a:lnSpc>
           <a:spcPct val="100000"/>
         </a:lnSpc>
@@ -5213,7 +5370,7 @@
           <a:spcPts val="0"/>
         </a:spcAft>
       </a:defPPr>
-      <a:lvl1pPr lvl="0" marR="0" rtl="0" algn="l">
+      <a:lvl1pPr marR="0" lvl="0" algn="l" rtl="0">
         <a:lnSpc>
           <a:spcPct val="100000"/>
         </a:lnSpc>
@@ -5227,7 +5384,7 @@
           <a:srgbClr val="000000"/>
         </a:buClr>
         <a:buFont typeface="Arial"/>
-        <a:defRPr b="0" i="0" sz="1400" u="none" cap="none" strike="noStrike">
+        <a:defRPr sz="1400" b="0" i="0" u="none" strike="noStrike" cap="none">
           <a:solidFill>
             <a:srgbClr val="000000"/>
           </a:solidFill>
@@ -5237,7 +5394,7 @@
           <a:sym typeface="Arial"/>
         </a:defRPr>
       </a:lvl1pPr>
-      <a:lvl2pPr lvl="1" marR="0" rtl="0" algn="l">
+      <a:lvl2pPr marR="0" lvl="1" algn="l" rtl="0">
         <a:lnSpc>
           <a:spcPct val="100000"/>
         </a:lnSpc>
@@ -5251,7 +5408,7 @@
           <a:srgbClr val="000000"/>
         </a:buClr>
         <a:buFont typeface="Arial"/>
-        <a:defRPr b="0" i="0" sz="1400" u="none" cap="none" strike="noStrike">
+        <a:defRPr sz="1400" b="0" i="0" u="none" strike="noStrike" cap="none">
           <a:solidFill>
             <a:srgbClr val="000000"/>
           </a:solidFill>
@@ -5261,7 +5418,7 @@
           <a:sym typeface="Arial"/>
         </a:defRPr>
       </a:lvl2pPr>
-      <a:lvl3pPr lvl="2" marR="0" rtl="0" algn="l">
+      <a:lvl3pPr marR="0" lvl="2" algn="l" rtl="0">
         <a:lnSpc>
           <a:spcPct val="100000"/>
         </a:lnSpc>
@@ -5275,7 +5432,7 @@
           <a:srgbClr val="000000"/>
         </a:buClr>
         <a:buFont typeface="Arial"/>
-        <a:defRPr b="0" i="0" sz="1400" u="none" cap="none" strike="noStrike">
+        <a:defRPr sz="1400" b="0" i="0" u="none" strike="noStrike" cap="none">
           <a:solidFill>
             <a:srgbClr val="000000"/>
           </a:solidFill>
@@ -5285,7 +5442,7 @@
           <a:sym typeface="Arial"/>
         </a:defRPr>
       </a:lvl3pPr>
-      <a:lvl4pPr lvl="3" marR="0" rtl="0" algn="l">
+      <a:lvl4pPr marR="0" lvl="3" algn="l" rtl="0">
         <a:lnSpc>
           <a:spcPct val="100000"/>
         </a:lnSpc>
@@ -5299,7 +5456,7 @@
           <a:srgbClr val="000000"/>
         </a:buClr>
         <a:buFont typeface="Arial"/>
-        <a:defRPr b="0" i="0" sz="1400" u="none" cap="none" strike="noStrike">
+        <a:defRPr sz="1400" b="0" i="0" u="none" strike="noStrike" cap="none">
           <a:solidFill>
             <a:srgbClr val="000000"/>
           </a:solidFill>
@@ -5309,7 +5466,7 @@
           <a:sym typeface="Arial"/>
         </a:defRPr>
       </a:lvl4pPr>
-      <a:lvl5pPr lvl="4" marR="0" rtl="0" algn="l">
+      <a:lvl5pPr marR="0" lvl="4" algn="l" rtl="0">
         <a:lnSpc>
           <a:spcPct val="100000"/>
         </a:lnSpc>
@@ -5323,7 +5480,7 @@
           <a:srgbClr val="000000"/>
         </a:buClr>
         <a:buFont typeface="Arial"/>
-        <a:defRPr b="0" i="0" sz="1400" u="none" cap="none" strike="noStrike">
+        <a:defRPr sz="1400" b="0" i="0" u="none" strike="noStrike" cap="none">
           <a:solidFill>
             <a:srgbClr val="000000"/>
           </a:solidFill>
@@ -5333,7 +5490,7 @@
           <a:sym typeface="Arial"/>
         </a:defRPr>
       </a:lvl5pPr>
-      <a:lvl6pPr lvl="5" marR="0" rtl="0" algn="l">
+      <a:lvl6pPr marR="0" lvl="5" algn="l" rtl="0">
         <a:lnSpc>
           <a:spcPct val="100000"/>
         </a:lnSpc>
@@ -5347,7 +5504,7 @@
           <a:srgbClr val="000000"/>
         </a:buClr>
         <a:buFont typeface="Arial"/>
-        <a:defRPr b="0" i="0" sz="1400" u="none" cap="none" strike="noStrike">
+        <a:defRPr sz="1400" b="0" i="0" u="none" strike="noStrike" cap="none">
           <a:solidFill>
             <a:srgbClr val="000000"/>
           </a:solidFill>
@@ -5357,7 +5514,7 @@
           <a:sym typeface="Arial"/>
         </a:defRPr>
       </a:lvl6pPr>
-      <a:lvl7pPr lvl="6" marR="0" rtl="0" algn="l">
+      <a:lvl7pPr marR="0" lvl="6" algn="l" rtl="0">
         <a:lnSpc>
           <a:spcPct val="100000"/>
         </a:lnSpc>
@@ -5371,7 +5528,7 @@
           <a:srgbClr val="000000"/>
         </a:buClr>
         <a:buFont typeface="Arial"/>
-        <a:defRPr b="0" i="0" sz="1400" u="none" cap="none" strike="noStrike">
+        <a:defRPr sz="1400" b="0" i="0" u="none" strike="noStrike" cap="none">
           <a:solidFill>
             <a:srgbClr val="000000"/>
           </a:solidFill>
@@ -5381,7 +5538,7 @@
           <a:sym typeface="Arial"/>
         </a:defRPr>
       </a:lvl7pPr>
-      <a:lvl8pPr lvl="7" marR="0" rtl="0" algn="l">
+      <a:lvl8pPr marR="0" lvl="7" algn="l" rtl="0">
         <a:lnSpc>
           <a:spcPct val="100000"/>
         </a:lnSpc>
@@ -5395,7 +5552,7 @@
           <a:srgbClr val="000000"/>
         </a:buClr>
         <a:buFont typeface="Arial"/>
-        <a:defRPr b="0" i="0" sz="1400" u="none" cap="none" strike="noStrike">
+        <a:defRPr sz="1400" b="0" i="0" u="none" strike="noStrike" cap="none">
           <a:solidFill>
             <a:srgbClr val="000000"/>
           </a:solidFill>
@@ -5405,7 +5562,7 @@
           <a:sym typeface="Arial"/>
         </a:defRPr>
       </a:lvl8pPr>
-      <a:lvl9pPr lvl="8" marR="0" rtl="0" algn="l">
+      <a:lvl9pPr marR="0" lvl="8" algn="l" rtl="0">
         <a:lnSpc>
           <a:spcPct val="100000"/>
         </a:lnSpc>
@@ -5419,7 +5576,7 @@
           <a:srgbClr val="000000"/>
         </a:buClr>
         <a:buFont typeface="Arial"/>
-        <a:defRPr b="0" i="0" sz="1400" u="none" cap="none" strike="noStrike">
+        <a:defRPr sz="1400" b="0" i="0" u="none" strike="noStrike" cap="none">
           <a:solidFill>
             <a:srgbClr val="000000"/>
           </a:solidFill>
@@ -5435,11 +5592,11 @@
 </file>
 
 <file path=ppt/slides/slide1.xml><?xml version="1.0" encoding="utf-8"?>
-<p:sld xmlns:a="http://schemas.openxmlformats.org/drawingml/2006/main" xmlns:r="http://schemas.openxmlformats.org/officeDocument/2006/relationships" xmlns:mc="http://schemas.openxmlformats.org/markup-compatibility/2006" xmlns:mv="urn:schemas-microsoft-com:mac:vml" xmlns:p="http://schemas.openxmlformats.org/presentationml/2006/main" xmlns:c="http://schemas.openxmlformats.org/drawingml/2006/chart" xmlns:dgm="http://schemas.openxmlformats.org/drawingml/2006/diagram" xmlns:o="urn:schemas-microsoft-com:office:office" xmlns:v="urn:schemas-microsoft-com:vml" xmlns:pvml="urn:schemas-microsoft-com:office:powerpoint" xmlns:com="http://schemas.openxmlformats.org/drawingml/2006/compatibility" xmlns:p14="http://schemas.microsoft.com/office/powerpoint/2010/main" xmlns:p15="http://schemas.microsoft.com/office/powerpoint/2012/main" xmlns:ahyp="http://schemas.microsoft.com/office/drawing/2018/hyperlinkcolor">
+<p:sld xmlns:a="http://schemas.openxmlformats.org/drawingml/2006/main" xmlns:r="http://schemas.openxmlformats.org/officeDocument/2006/relationships" xmlns:p="http://schemas.openxmlformats.org/presentationml/2006/main">
   <p:cSld>
     <p:spTree>
       <p:nvGrpSpPr>
-        <p:cNvPr id="53" name="Shape 53"/>
+        <p:cNvPr id="1" name="Shape 53"/>
         <p:cNvGrpSpPr/>
         <p:nvPr/>
       </p:nvGrpSpPr>
@@ -5458,24 +5615,24 @@
           <p:nvPr/>
         </p:nvCxnSpPr>
         <p:spPr>
-          <a:xfrm flipH="1" rot="5400000">
+          <a:xfrm rot="5400000" flipH="1">
             <a:off x="3431675" y="-89500"/>
             <a:ext cx="23700" cy="7800"/>
           </a:xfrm>
           <a:prstGeom prst="bentConnector3">
             <a:avLst>
-              <a:gd fmla="val 50000" name="adj1"/>
+              <a:gd name="adj1" fmla="val 50000"/>
             </a:avLst>
           </a:prstGeom>
           <a:noFill/>
-          <a:ln cap="flat" cmpd="sng" w="9525">
+          <a:ln w="9525" cap="flat" cmpd="sng">
             <a:solidFill>
               <a:schemeClr val="dk2"/>
             </a:solidFill>
             <a:prstDash val="solid"/>
             <a:round/>
-            <a:headEnd len="med" w="med" type="none"/>
-            <a:tailEnd len="med" w="med" type="none"/>
+            <a:headEnd type="none" w="med" len="med"/>
+            <a:tailEnd type="none" w="med" len="med"/>
           </a:ln>
         </p:spPr>
       </p:cxnSp>
@@ -5520,29 +5677,29 @@
               </a:xfrm>
               <a:prstGeom prst="roundRect">
                 <a:avLst>
-                  <a:gd fmla="val 16667" name="adj"/>
+                  <a:gd name="adj" fmla="val 16667"/>
                 </a:avLst>
               </a:prstGeom>
               <a:solidFill>
                 <a:srgbClr val="93C47D"/>
               </a:solidFill>
-              <a:ln cap="flat" cmpd="sng" w="9525">
+              <a:ln w="9525" cap="flat" cmpd="sng">
                 <a:solidFill>
                   <a:schemeClr val="dk2"/>
                 </a:solidFill>
                 <a:prstDash val="solid"/>
                 <a:round/>
-                <a:headEnd len="sm" w="sm" type="none"/>
-                <a:tailEnd len="sm" w="sm" type="none"/>
+                <a:headEnd type="none" w="sm" len="sm"/>
+                <a:tailEnd type="none" w="sm" len="sm"/>
               </a:ln>
             </p:spPr>
             <p:txBody>
-              <a:bodyPr anchorCtr="0" anchor="ctr" bIns="91425" lIns="91425" spcFirstLastPara="1" rIns="91425" wrap="square" tIns="91425">
+              <a:bodyPr spcFirstLastPara="1" wrap="square" lIns="91425" tIns="91425" rIns="91425" bIns="91425" anchor="ctr" anchorCtr="0">
                 <a:noAutofit/>
               </a:bodyPr>
               <a:lstStyle/>
               <a:p>
-                <a:pPr indent="0" lvl="0" marL="0" rtl="0" algn="ctr">
+                <a:pPr marL="0" lvl="0" indent="0" algn="ctr" rtl="0">
                   <a:spcBef>
                     <a:spcPts val="0"/>
                   </a:spcBef>
@@ -5551,9 +5708,6 @@
                   </a:spcAft>
                   <a:buNone/>
                 </a:pPr>
-                <a:r>
-                  <a:t/>
-                </a:r>
                 <a:endParaRPr/>
               </a:p>
             </p:txBody>
@@ -5578,12 +5732,12 @@
               </a:ln>
             </p:spPr>
             <p:txBody>
-              <a:bodyPr anchorCtr="0" anchor="t" bIns="91425" lIns="91425" spcFirstLastPara="1" rIns="91425" wrap="square" tIns="91425">
+              <a:bodyPr spcFirstLastPara="1" wrap="square" lIns="91425" tIns="91425" rIns="91425" bIns="91425" anchor="t" anchorCtr="0">
                 <a:noAutofit/>
               </a:bodyPr>
               <a:lstStyle/>
               <a:p>
-                <a:pPr indent="0" lvl="0" marL="0" rtl="0" algn="ctr">
+                <a:pPr marL="0" lvl="0" indent="0" algn="ctr" rtl="0">
                   <a:spcBef>
                     <a:spcPts val="0"/>
                   </a:spcBef>
@@ -5593,21 +5747,21 @@
                   <a:buNone/>
                 </a:pPr>
                 <a:r>
-                  <a:rPr b="1" lang="en" sz="1800" u="sng">
+                  <a:rPr lang="en" sz="1800" b="1" u="sng">
                     <a:solidFill>
                       <a:schemeClr val="dk2"/>
                     </a:solidFill>
                   </a:rPr>
                   <a:t>GOanna</a:t>
                 </a:r>
-                <a:endParaRPr b="1" sz="1800" u="sng">
+                <a:endParaRPr sz="1800" b="1" u="sng">
                   <a:solidFill>
                     <a:schemeClr val="dk2"/>
                   </a:solidFill>
                 </a:endParaRPr>
               </a:p>
               <a:p>
-                <a:pPr indent="0" lvl="0" marL="0" rtl="0" algn="ctr">
+                <a:pPr marL="0" lvl="0" indent="0" algn="ctr" rtl="0">
                   <a:spcBef>
                     <a:spcPts val="0"/>
                   </a:spcBef>
@@ -5660,29 +5814,29 @@
               </a:xfrm>
               <a:prstGeom prst="roundRect">
                 <a:avLst>
-                  <a:gd fmla="val 16667" name="adj"/>
+                  <a:gd name="adj" fmla="val 16667"/>
                 </a:avLst>
               </a:prstGeom>
               <a:solidFill>
                 <a:srgbClr val="EA9999"/>
               </a:solidFill>
-              <a:ln cap="flat" cmpd="sng" w="9525">
+              <a:ln w="9525" cap="flat" cmpd="sng">
                 <a:solidFill>
                   <a:schemeClr val="dk2"/>
                 </a:solidFill>
                 <a:prstDash val="solid"/>
                 <a:round/>
-                <a:headEnd len="sm" w="sm" type="none"/>
-                <a:tailEnd len="sm" w="sm" type="none"/>
+                <a:headEnd type="none" w="sm" len="sm"/>
+                <a:tailEnd type="none" w="sm" len="sm"/>
               </a:ln>
             </p:spPr>
             <p:txBody>
-              <a:bodyPr anchorCtr="0" anchor="ctr" bIns="91425" lIns="91425" spcFirstLastPara="1" rIns="91425" wrap="square" tIns="91425">
+              <a:bodyPr spcFirstLastPara="1" wrap="square" lIns="91425" tIns="91425" rIns="91425" bIns="91425" anchor="ctr" anchorCtr="0">
                 <a:noAutofit/>
               </a:bodyPr>
               <a:lstStyle/>
               <a:p>
-                <a:pPr indent="0" lvl="0" marL="0" rtl="0" algn="ctr">
+                <a:pPr marL="0" lvl="0" indent="0" algn="ctr" rtl="0">
                   <a:spcBef>
                     <a:spcPts val="0"/>
                   </a:spcBef>
@@ -5691,9 +5845,6 @@
                   </a:spcAft>
                   <a:buNone/>
                 </a:pPr>
-                <a:r>
-                  <a:t/>
-                </a:r>
                 <a:endParaRPr/>
               </a:p>
             </p:txBody>
@@ -5718,12 +5869,12 @@
               </a:ln>
             </p:spPr>
             <p:txBody>
-              <a:bodyPr anchorCtr="0" anchor="t" bIns="91425" lIns="91425" spcFirstLastPara="1" rIns="91425" wrap="square" tIns="91425">
+              <a:bodyPr spcFirstLastPara="1" wrap="square" lIns="91425" tIns="91425" rIns="91425" bIns="91425" anchor="t" anchorCtr="0">
                 <a:noAutofit/>
               </a:bodyPr>
               <a:lstStyle/>
               <a:p>
-                <a:pPr indent="0" lvl="0" marL="0" rtl="0" algn="ctr">
+                <a:pPr marL="0" lvl="0" indent="0" algn="ctr" rtl="0">
                   <a:spcBef>
                     <a:spcPts val="0"/>
                   </a:spcBef>
@@ -5733,21 +5884,21 @@
                   <a:buNone/>
                 </a:pPr>
                 <a:r>
-                  <a:rPr b="1" lang="en" sz="1800" u="sng">
+                  <a:rPr lang="en" sz="1800" b="1" u="sng">
                     <a:solidFill>
                       <a:schemeClr val="dk2"/>
                     </a:solidFill>
                   </a:rPr>
                   <a:t>InterProScan</a:t>
                 </a:r>
-                <a:endParaRPr b="1" sz="1800" u="sng">
+                <a:endParaRPr sz="1800" b="1" u="sng">
                   <a:solidFill>
                     <a:schemeClr val="dk2"/>
                   </a:solidFill>
                 </a:endParaRPr>
               </a:p>
               <a:p>
-                <a:pPr indent="0" lvl="0" marL="0" rtl="0" algn="ctr">
+                <a:pPr marL="0" lvl="0" indent="0" algn="ctr" rtl="0">
                   <a:spcBef>
                     <a:spcPts val="0"/>
                   </a:spcBef>
@@ -5800,29 +5951,29 @@
               </a:xfrm>
               <a:prstGeom prst="roundRect">
                 <a:avLst>
-                  <a:gd fmla="val 16667" name="adj"/>
+                  <a:gd name="adj" fmla="val 16667"/>
                 </a:avLst>
               </a:prstGeom>
               <a:solidFill>
                 <a:srgbClr val="B4A7D6"/>
               </a:solidFill>
-              <a:ln cap="flat" cmpd="sng" w="9525">
+              <a:ln w="9525" cap="flat" cmpd="sng">
                 <a:solidFill>
                   <a:schemeClr val="dk2"/>
                 </a:solidFill>
                 <a:prstDash val="solid"/>
                 <a:round/>
-                <a:headEnd len="sm" w="sm" type="none"/>
-                <a:tailEnd len="sm" w="sm" type="none"/>
+                <a:headEnd type="none" w="sm" len="sm"/>
+                <a:tailEnd type="none" w="sm" len="sm"/>
               </a:ln>
             </p:spPr>
             <p:txBody>
-              <a:bodyPr anchorCtr="0" anchor="ctr" bIns="91425" lIns="91425" spcFirstLastPara="1" rIns="91425" wrap="square" tIns="91425">
+              <a:bodyPr spcFirstLastPara="1" wrap="square" lIns="91425" tIns="91425" rIns="91425" bIns="91425" anchor="ctr" anchorCtr="0">
                 <a:noAutofit/>
               </a:bodyPr>
               <a:lstStyle/>
               <a:p>
-                <a:pPr indent="0" lvl="0" marL="0" rtl="0" algn="ctr">
+                <a:pPr marL="0" lvl="0" indent="0" algn="ctr" rtl="0">
                   <a:spcBef>
                     <a:spcPts val="0"/>
                   </a:spcBef>
@@ -5831,9 +5982,6 @@
                   </a:spcAft>
                   <a:buNone/>
                 </a:pPr>
-                <a:r>
-                  <a:t/>
-                </a:r>
                 <a:endParaRPr/>
               </a:p>
             </p:txBody>
@@ -5858,12 +6006,12 @@
               </a:ln>
             </p:spPr>
             <p:txBody>
-              <a:bodyPr anchorCtr="0" anchor="t" bIns="91425" lIns="91425" spcFirstLastPara="1" rIns="91425" wrap="square" tIns="91425">
+              <a:bodyPr spcFirstLastPara="1" wrap="square" lIns="91425" tIns="91425" rIns="91425" bIns="91425" anchor="t" anchorCtr="0">
                 <a:noAutofit/>
               </a:bodyPr>
               <a:lstStyle/>
               <a:p>
-                <a:pPr indent="0" lvl="0" marL="0" rtl="0" algn="ctr">
+                <a:pPr marL="0" lvl="0" indent="0" algn="ctr" rtl="0">
                   <a:spcBef>
                     <a:spcPts val="0"/>
                   </a:spcBef>
@@ -5873,21 +6021,21 @@
                   <a:buNone/>
                 </a:pPr>
                 <a:r>
-                  <a:rPr b="1" lang="en" sz="1800" u="sng">
+                  <a:rPr lang="en" sz="1800" b="1" u="sng" dirty="0">
                     <a:solidFill>
                       <a:schemeClr val="dk2"/>
                     </a:solidFill>
                   </a:rPr>
                   <a:t>Pathannotator</a:t>
                 </a:r>
-                <a:endParaRPr b="1" sz="1800" u="sng">
+                <a:endParaRPr sz="1800" b="1" u="sng" dirty="0">
                   <a:solidFill>
                     <a:schemeClr val="dk2"/>
                   </a:solidFill>
                 </a:endParaRPr>
               </a:p>
               <a:p>
-                <a:pPr indent="0" lvl="0" marL="0" rtl="0" algn="ctr">
+                <a:pPr marL="0" lvl="0" indent="0" algn="ctr" rtl="0">
                   <a:spcBef>
                     <a:spcPts val="0"/>
                   </a:spcBef>
@@ -5902,9 +6050,9 @@
                       <a:schemeClr val="dk2"/>
                     </a:solidFill>
                   </a:rPr>
-                  <a:t>KEGG and FlyBase pathways annotation</a:t>
+                  <a:t>KEGG, FlyBase and Reactome pathways annotation</a:t>
                 </a:r>
-                <a:endParaRPr sz="1300">
+                <a:endParaRPr sz="1300" dirty="0">
                   <a:solidFill>
                     <a:schemeClr val="dk2"/>
                   </a:solidFill>
@@ -5940,29 +6088,29 @@
               </a:xfrm>
               <a:prstGeom prst="roundRect">
                 <a:avLst>
-                  <a:gd fmla="val 16667" name="adj"/>
+                  <a:gd name="adj" fmla="val 16667"/>
                 </a:avLst>
               </a:prstGeom>
               <a:solidFill>
                 <a:srgbClr val="FFE599"/>
               </a:solidFill>
-              <a:ln cap="flat" cmpd="sng" w="9525">
+              <a:ln w="9525" cap="flat" cmpd="sng">
                 <a:solidFill>
                   <a:schemeClr val="dk2"/>
                 </a:solidFill>
                 <a:prstDash val="solid"/>
                 <a:round/>
-                <a:headEnd len="sm" w="sm" type="none"/>
-                <a:tailEnd len="sm" w="sm" type="none"/>
+                <a:headEnd type="none" w="sm" len="sm"/>
+                <a:tailEnd type="none" w="sm" len="sm"/>
               </a:ln>
             </p:spPr>
             <p:txBody>
-              <a:bodyPr anchorCtr="0" anchor="ctr" bIns="91425" lIns="91425" spcFirstLastPara="1" rIns="91425" wrap="square" tIns="91425">
+              <a:bodyPr spcFirstLastPara="1" wrap="square" lIns="91425" tIns="91425" rIns="91425" bIns="91425" anchor="ctr" anchorCtr="0">
                 <a:noAutofit/>
               </a:bodyPr>
               <a:lstStyle/>
               <a:p>
-                <a:pPr indent="0" lvl="0" marL="0" rtl="0" algn="ctr">
+                <a:pPr marL="0" lvl="0" indent="0" algn="ctr" rtl="0">
                   <a:spcBef>
                     <a:spcPts val="0"/>
                   </a:spcBef>
@@ -5971,9 +6119,6 @@
                   </a:spcAft>
                   <a:buNone/>
                 </a:pPr>
-                <a:r>
-                  <a:t/>
-                </a:r>
                 <a:endParaRPr/>
               </a:p>
             </p:txBody>
@@ -5998,12 +6143,12 @@
               </a:ln>
             </p:spPr>
             <p:txBody>
-              <a:bodyPr anchorCtr="0" anchor="t" bIns="91425" lIns="91425" spcFirstLastPara="1" rIns="91425" wrap="square" tIns="91425">
+              <a:bodyPr spcFirstLastPara="1" wrap="square" lIns="91425" tIns="91425" rIns="91425" bIns="91425" anchor="t" anchorCtr="0">
                 <a:noAutofit/>
               </a:bodyPr>
               <a:lstStyle/>
               <a:p>
-                <a:pPr indent="0" lvl="0" marL="0" rtl="0" algn="ctr">
+                <a:pPr marL="0" lvl="0" indent="0" algn="ctr" rtl="0">
                   <a:spcBef>
                     <a:spcPts val="0"/>
                   </a:spcBef>
@@ -6013,21 +6158,21 @@
                   <a:buNone/>
                 </a:pPr>
                 <a:r>
-                  <a:rPr b="1" lang="en" sz="1800" u="sng">
+                  <a:rPr lang="en" sz="1800" b="1" u="sng">
                     <a:solidFill>
                       <a:schemeClr val="dk2"/>
                     </a:solidFill>
                   </a:rPr>
                   <a:t>combine GAFs</a:t>
                 </a:r>
-                <a:endParaRPr b="1" sz="1800" u="sng">
+                <a:endParaRPr sz="1800" b="1" u="sng">
                   <a:solidFill>
                     <a:schemeClr val="dk2"/>
                   </a:solidFill>
                 </a:endParaRPr>
               </a:p>
               <a:p>
-                <a:pPr indent="0" lvl="0" marL="0" rtl="0" algn="ctr">
+                <a:pPr marL="0" lvl="0" indent="0" algn="ctr" rtl="0">
                   <a:spcBef>
                     <a:spcPts val="0"/>
                   </a:spcBef>
@@ -6080,29 +6225,29 @@
               </a:xfrm>
               <a:prstGeom prst="roundRect">
                 <a:avLst>
-                  <a:gd fmla="val 16667" name="adj"/>
+                  <a:gd name="adj" fmla="val 16667"/>
                 </a:avLst>
               </a:prstGeom>
               <a:solidFill>
                 <a:srgbClr val="9FC5E8"/>
               </a:solidFill>
-              <a:ln cap="flat" cmpd="sng" w="9525">
+              <a:ln w="9525" cap="flat" cmpd="sng">
                 <a:solidFill>
                   <a:schemeClr val="dk2"/>
                 </a:solidFill>
                 <a:prstDash val="solid"/>
                 <a:round/>
-                <a:headEnd len="sm" w="sm" type="none"/>
-                <a:tailEnd len="sm" w="sm" type="none"/>
+                <a:headEnd type="none" w="sm" len="sm"/>
+                <a:tailEnd type="none" w="sm" len="sm"/>
               </a:ln>
             </p:spPr>
             <p:txBody>
-              <a:bodyPr anchorCtr="0" anchor="ctr" bIns="91425" lIns="91425" spcFirstLastPara="1" rIns="91425" wrap="square" tIns="91425">
+              <a:bodyPr spcFirstLastPara="1" wrap="square" lIns="91425" tIns="91425" rIns="91425" bIns="91425" anchor="ctr" anchorCtr="0">
                 <a:noAutofit/>
               </a:bodyPr>
               <a:lstStyle/>
               <a:p>
-                <a:pPr indent="0" lvl="0" marL="0" rtl="0" algn="ctr">
+                <a:pPr marL="0" lvl="0" indent="0" algn="ctr" rtl="0">
                   <a:spcBef>
                     <a:spcPts val="0"/>
                   </a:spcBef>
@@ -6111,9 +6256,6 @@
                   </a:spcAft>
                   <a:buNone/>
                 </a:pPr>
-                <a:r>
-                  <a:t/>
-                </a:r>
                 <a:endParaRPr/>
               </a:p>
             </p:txBody>
@@ -6138,12 +6280,12 @@
               </a:ln>
             </p:spPr>
             <p:txBody>
-              <a:bodyPr anchorCtr="0" anchor="t" bIns="91425" lIns="91425" spcFirstLastPara="1" rIns="91425" wrap="square" tIns="91425">
+              <a:bodyPr spcFirstLastPara="1" wrap="square" lIns="91425" tIns="91425" rIns="91425" bIns="91425" anchor="t" anchorCtr="0">
                 <a:noAutofit/>
               </a:bodyPr>
               <a:lstStyle/>
               <a:p>
-                <a:pPr indent="0" lvl="0" marL="0" rtl="0" algn="ctr">
+                <a:pPr marL="0" lvl="0" indent="0" algn="ctr" rtl="0">
                   <a:spcBef>
                     <a:spcPts val="0"/>
                   </a:spcBef>
@@ -6153,14 +6295,14 @@
                   <a:buNone/>
                 </a:pPr>
                 <a:r>
-                  <a:rPr b="1" lang="en" sz="1800">
+                  <a:rPr lang="en" sz="1800" b="1">
                     <a:solidFill>
                       <a:schemeClr val="dk2"/>
                     </a:solidFill>
                   </a:rPr>
                   <a:t>Protein FASTA</a:t>
                 </a:r>
-                <a:endParaRPr b="1" sz="1800">
+                <a:endParaRPr sz="1800" b="1">
                   <a:solidFill>
                     <a:schemeClr val="dk2"/>
                   </a:solidFill>
@@ -6187,14 +6329,14 @@
               <a:avLst/>
             </a:prstGeom>
             <a:noFill/>
-            <a:ln cap="flat" cmpd="sng" w="28575">
+            <a:ln w="28575" cap="flat" cmpd="sng">
               <a:solidFill>
                 <a:schemeClr val="dk2"/>
               </a:solidFill>
               <a:prstDash val="solid"/>
               <a:round/>
-              <a:headEnd len="med" w="med" type="none"/>
-              <a:tailEnd len="med" w="med" type="none"/>
+              <a:headEnd type="none" w="med" len="med"/>
+              <a:tailEnd type="none" w="med" len="med"/>
             </a:ln>
           </p:spPr>
         </p:cxnSp>
@@ -6215,14 +6357,14 @@
               <a:avLst/>
             </a:prstGeom>
             <a:noFill/>
-            <a:ln cap="flat" cmpd="sng" w="28575">
+            <a:ln w="28575" cap="flat" cmpd="sng">
               <a:solidFill>
                 <a:schemeClr val="dk2"/>
               </a:solidFill>
               <a:prstDash val="solid"/>
               <a:round/>
-              <a:headEnd len="med" w="med" type="none"/>
-              <a:tailEnd len="med" w="med" type="none"/>
+              <a:headEnd type="none" w="med" len="med"/>
+              <a:tailEnd type="none" w="med" len="med"/>
             </a:ln>
           </p:spPr>
         </p:cxnSp>
@@ -6241,18 +6383,18 @@
             </a:xfrm>
             <a:prstGeom prst="bentConnector3">
               <a:avLst>
-                <a:gd fmla="val 340" name="adj1"/>
+                <a:gd name="adj1" fmla="val 340"/>
               </a:avLst>
             </a:prstGeom>
             <a:noFill/>
-            <a:ln cap="flat" cmpd="sng" w="9525">
+            <a:ln w="9525" cap="flat" cmpd="sng">
               <a:solidFill>
                 <a:schemeClr val="dk2"/>
               </a:solidFill>
               <a:prstDash val="solid"/>
               <a:round/>
-              <a:headEnd len="med" w="med" type="none"/>
-              <a:tailEnd len="med" w="med" type="none"/>
+              <a:headEnd type="none" w="med" len="med"/>
+              <a:tailEnd type="none" w="med" len="med"/>
             </a:ln>
           </p:spPr>
         </p:cxnSp>
@@ -6273,14 +6415,14 @@
               <a:avLst/>
             </a:prstGeom>
             <a:noFill/>
-            <a:ln cap="flat" cmpd="sng" w="9525">
+            <a:ln w="9525" cap="flat" cmpd="sng">
               <a:solidFill>
                 <a:schemeClr val="dk2"/>
               </a:solidFill>
               <a:prstDash val="solid"/>
               <a:round/>
-              <a:headEnd len="med" w="med" type="none"/>
-              <a:tailEnd len="med" w="med" type="none"/>
+              <a:headEnd type="none" w="med" len="med"/>
+              <a:tailEnd type="none" w="med" len="med"/>
             </a:ln>
           </p:spPr>
         </p:cxnSp>
@@ -6301,14 +6443,14 @@
               <a:avLst/>
             </a:prstGeom>
             <a:noFill/>
-            <a:ln cap="flat" cmpd="sng" w="9525">
+            <a:ln w="9525" cap="flat" cmpd="sng">
               <a:solidFill>
                 <a:schemeClr val="dk2"/>
               </a:solidFill>
               <a:prstDash val="solid"/>
               <a:round/>
-              <a:headEnd len="med" w="med" type="none"/>
-              <a:tailEnd len="med" w="med" type="none"/>
+              <a:headEnd type="none" w="med" len="med"/>
+              <a:tailEnd type="none" w="med" len="med"/>
             </a:ln>
           </p:spPr>
         </p:cxnSp>
@@ -6327,14 +6469,14 @@
               <a:avLst/>
             </a:prstGeom>
             <a:noFill/>
-            <a:ln cap="flat" cmpd="sng" w="28575">
+            <a:ln w="28575" cap="flat" cmpd="sng">
               <a:solidFill>
                 <a:schemeClr val="dk2"/>
               </a:solidFill>
               <a:prstDash val="solid"/>
               <a:round/>
-              <a:headEnd len="med" w="med" type="none"/>
-              <a:tailEnd len="med" w="med" type="triangle"/>
+              <a:headEnd type="none" w="med" len="med"/>
+              <a:tailEnd type="triangle" w="med" len="med"/>
             </a:ln>
           </p:spPr>
         </p:cxnSp>
@@ -6355,14 +6497,14 @@
               <a:avLst/>
             </a:prstGeom>
             <a:noFill/>
-            <a:ln cap="flat" cmpd="sng" w="28575">
+            <a:ln w="28575" cap="flat" cmpd="sng">
               <a:solidFill>
                 <a:schemeClr val="dk2"/>
               </a:solidFill>
               <a:prstDash val="solid"/>
               <a:round/>
-              <a:headEnd len="med" w="med" type="none"/>
-              <a:tailEnd len="med" w="med" type="triangle"/>
+              <a:headEnd type="none" w="med" len="med"/>
+              <a:tailEnd type="triangle" w="med" len="med"/>
             </a:ln>
           </p:spPr>
         </p:cxnSp>
@@ -6383,14 +6525,14 @@
               <a:avLst/>
             </a:prstGeom>
             <a:noFill/>
-            <a:ln cap="flat" cmpd="sng" w="28575">
+            <a:ln w="28575" cap="flat" cmpd="sng">
               <a:solidFill>
                 <a:schemeClr val="dk2"/>
               </a:solidFill>
               <a:prstDash val="solid"/>
               <a:round/>
-              <a:headEnd len="med" w="med" type="none"/>
-              <a:tailEnd len="med" w="med" type="triangle"/>
+              <a:headEnd type="none" w="med" len="med"/>
+              <a:tailEnd type="triangle" w="med" len="med"/>
             </a:ln>
           </p:spPr>
         </p:cxnSp>
@@ -6411,14 +6553,14 @@
               <a:avLst/>
             </a:prstGeom>
             <a:noFill/>
-            <a:ln cap="flat" cmpd="sng" w="28575">
+            <a:ln w="28575" cap="flat" cmpd="sng">
               <a:solidFill>
                 <a:schemeClr val="dk2"/>
               </a:solidFill>
               <a:prstDash val="solid"/>
               <a:round/>
-              <a:headEnd len="med" w="med" type="none"/>
-              <a:tailEnd len="med" w="med" type="triangle"/>
+              <a:headEnd type="none" w="med" len="med"/>
+              <a:tailEnd type="triangle" w="med" len="med"/>
             </a:ln>
           </p:spPr>
         </p:cxnSp>
@@ -6431,7 +6573,7 @@
             <p:nvPr/>
           </p:nvCxnSpPr>
           <p:spPr>
-            <a:xfrm flipH="1" rot="10800000">
+            <a:xfrm rot="10800000" flipH="1">
               <a:off x="1508238" y="4429800"/>
               <a:ext cx="2259900" cy="5100"/>
             </a:xfrm>
@@ -6439,14 +6581,14 @@
               <a:avLst/>
             </a:prstGeom>
             <a:noFill/>
-            <a:ln cap="flat" cmpd="sng" w="28575">
+            <a:ln w="28575" cap="flat" cmpd="sng">
               <a:solidFill>
                 <a:schemeClr val="dk2"/>
               </a:solidFill>
               <a:prstDash val="solid"/>
               <a:round/>
-              <a:headEnd len="med" w="med" type="none"/>
-              <a:tailEnd len="med" w="med" type="triangle"/>
+              <a:headEnd type="none" w="med" len="med"/>
+              <a:tailEnd type="triangle" w="med" len="med"/>
             </a:ln>
           </p:spPr>
         </p:cxnSp>
@@ -6465,14 +6607,14 @@
               <a:avLst/>
             </a:prstGeom>
             <a:noFill/>
-            <a:ln cap="flat" cmpd="sng" w="28575">
+            <a:ln w="28575" cap="flat" cmpd="sng">
               <a:solidFill>
                 <a:schemeClr val="dk2"/>
               </a:solidFill>
               <a:prstDash val="solid"/>
               <a:round/>
-              <a:headEnd len="med" w="med" type="none"/>
-              <a:tailEnd len="med" w="med" type="none"/>
+              <a:headEnd type="none" w="med" len="med"/>
+              <a:tailEnd type="none" w="med" len="med"/>
             </a:ln>
           </p:spPr>
         </p:cxnSp>
@@ -6486,7 +6628,7 @@
 </file>
 
 <file path=ppt/theme/theme1.xml><?xml version="1.0" encoding="utf-8"?>
-<a:theme xmlns:a="http://schemas.openxmlformats.org/drawingml/2006/main" xmlns:r="http://schemas.openxmlformats.org/officeDocument/2006/relationships" name="Simple Light">
+<a:theme xmlns:a="http://schemas.openxmlformats.org/drawingml/2006/main" name="Simple Light">
   <a:themeElements>
     <a:clrScheme name="Simple Light">
       <a:dk1>
@@ -6761,11 +6903,13 @@
       </a:bgFillStyleLst>
     </a:fmtScheme>
   </a:themeElements>
+  <a:objectDefaults/>
+  <a:extraClrSchemeLst/>
 </a:theme>
 </file>
 
 <file path=ppt/theme/theme2.xml><?xml version="1.0" encoding="utf-8"?>
-<a:theme xmlns:a="http://schemas.openxmlformats.org/drawingml/2006/main" xmlns:r="http://schemas.openxmlformats.org/officeDocument/2006/relationships">
+<a:theme xmlns:a="http://schemas.openxmlformats.org/drawingml/2006/main">
   <a:themeElements>
     <a:clrScheme name="Default">
       <a:dk1>
@@ -7040,5 +7184,13 @@
       </a:bgFillStyleLst>
     </a:fmtScheme>
   </a:themeElements>
+  <a:objectDefaults/>
+  <a:extraClrSchemeLst/>
 </a:theme>
+</file>
+
+<file path=docMetadata/LabelInfo.xml><?xml version="1.0" encoding="utf-8"?>
+<clbl:labelList xmlns:clbl="http://schemas.microsoft.com/office/2020/mipLabelMetadata">
+  <clbl:label id="{ed5b36e7-01ee-4ebc-867e-e03cfa0d4697}" enabled="0" method="" siteId="{ed5b36e7-01ee-4ebc-867e-e03cfa0d4697}" removed="1"/>
+</clbl:labelList>
 </file>
</xml_diff>